<commit_message>
Yussuf carousel: 5 slides, new cover photo, France moment, essays and academic part
Co-Authored-By: Claude Opus 5.5 <noreply@anthropic.com>
Claude-Session: https://claude.ai/code/session_01EUKBNPzc7y2DXSfnei23HU
</commit_message>
<xml_diff>
--- a/social/pptx/yussuf-1580.pptx
+++ b/social/pptx/yussuf-1580.pptx
@@ -9,9 +9,10 @@
     <p:sldId id="257" r:id="rId3"/>
     <p:sldId id="258" r:id="rId4"/>
     <p:sldId id="259" r:id="rId5"/>
+    <p:sldId id="260" r:id="rId6"/>
   </p:sldIdLst>
   <p:notesMasterIdLst>
-    <p:notesMasterId r:id="rId6"/>
+    <p:notesMasterId r:id="rId7"/>
   </p:notesMasterIdLst>
   <p:sldSz cx="6858000" cy="8572500"/>
   <p:notesSz cx="8572500" cy="6858000"/>
@@ -793,6 +794,94 @@
             <a:fld id="{F7021451-1387-4CA6-816F-3879F97B5CBC}" type="slidenum">
               <a:rPr lang="en-US"/>
               <a:t>4</a:t>
+            </a:fld>
+            <a:endParaRPr lang="en-US"/>
+          </a:p>
+        </p:txBody>
+      </p:sp>
+    </p:spTree>
+    <p:extLst>
+      <p:ext uri="{BB962C8B-B14F-4D97-AF65-F5344CB8AC3E}">
+        <p14:creationId xmlns:p14="http://schemas.microsoft.com/office/powerpoint/2010/main" val="1024086991"/>
+      </p:ext>
+    </p:extLst>
+  </p:cSld>
+  <p:clrMapOvr>
+    <a:masterClrMapping/>
+  </p:clrMapOvr>
+</p:notes>
+</file>
+
+<file path=ppt/notesSlides/notesSlide5.xml><?xml version="1.0" encoding="utf-8"?>
+<p:notes xmlns:a="http://schemas.openxmlformats.org/drawingml/2006/main" xmlns:r="http://schemas.openxmlformats.org/officeDocument/2006/relationships" xmlns:p="http://schemas.openxmlformats.org/presentationml/2006/main">
+  <p:cSld>
+    <p:spTree>
+      <p:nvGrpSpPr>
+        <p:cNvPr id="1" name=""/>
+        <p:cNvGrpSpPr/>
+        <p:nvPr/>
+      </p:nvGrpSpPr>
+      <p:grpSpPr>
+        <a:xfrm>
+          <a:off x="0" y="0"/>
+          <a:ext cx="0" cy="0"/>
+          <a:chOff x="0" y="0"/>
+          <a:chExt cx="0" cy="0"/>
+        </a:xfrm>
+      </p:grpSpPr>
+      <p:sp>
+        <p:nvSpPr>
+          <p:cNvPr id="2" name="Slide Image Placeholder 1"/>
+          <p:cNvSpPr>
+            <a:spLocks noGrp="1" noRot="1" noChangeAspect="1"/>
+          </p:cNvSpPr>
+          <p:nvPr>
+            <p:ph type="sldImg"/>
+          </p:nvPr>
+        </p:nvSpPr>
+        <p:spPr/>
+      </p:sp>
+      <p:sp>
+        <p:nvSpPr>
+          <p:cNvPr id="3" name="Notes Placeholder 2"/>
+          <p:cNvSpPr>
+            <a:spLocks noGrp="1"/>
+          </p:cNvSpPr>
+          <p:nvPr>
+            <p:ph type="body" idx="1"/>
+          </p:nvPr>
+        </p:nvSpPr>
+        <p:spPr/>
+        <p:txBody>
+          <a:bodyPr/>
+          <a:lstStyle/>
+          <a:p>
+            <a:r>
+              <a:rPr lang="en-US" dirty="0"/>
+              <a:t/>
+            </a:r>
+            <a:endParaRPr lang="en-US" dirty="0"/>
+          </a:p>
+        </p:txBody>
+      </p:sp>
+      <p:sp>
+        <p:nvSpPr>
+          <p:cNvPr id="4" name="Slide Number Placeholder 3"/>
+          <p:cNvSpPr>
+            <a:spLocks noGrp="1"/>
+          </p:cNvSpPr>
+          <p:nvPr>
+            <p:ph type="sldNum" sz="quarter" idx="10"/>
+          </p:nvPr>
+        </p:nvSpPr>
+        <p:spPr/>
+        <p:txBody>
+          <a:bodyPr/>
+          <a:lstStyle/>
+          <a:p>
+            <a:fld id="{F7021451-1387-4CA6-816F-3879F97B5CBC}" type="slidenum">
+              <a:rPr lang="en-US"/>
+              <a:t>5</a:t>
             </a:fld>
             <a:endParaRPr lang="en-US"/>
           </a:p>
@@ -1278,7 +1367,7 @@
                 <a:ea typeface="IBM Plex Mono" pitchFamily="34" charset="-122"/>
                 <a:cs typeface="IBM Plex Mono" pitchFamily="34" charset="-120"/>
               </a:rPr>
-              <a:t>01 / 04</a:t>
+              <a:t>01 / 05</a:t>
             </a:r>
             <a:endParaRPr lang="en-US" sz="1000" dirty="0"/>
           </a:p>
@@ -1379,7 +1468,7 @@
                 <a:ea typeface="Geist" pitchFamily="34" charset="-122"/>
                 <a:cs typeface="Geist" pitchFamily="34" charset="-120"/>
               </a:rPr>
-              <a:t>Это Юсуф, мой первый ученик и близкий друг. Вот как вырос его SAT.</a:t>
+              <a:t>Это Юсуф, мой первый ученик и близкий друг. Я сопровождаю его поступление, и вот как вырос его SAT.</a:t>
             </a:r>
             <a:endParaRPr lang="en-US" sz="1500" dirty="0"/>
           </a:p>
@@ -1392,9 +1481,9 @@
           <p:nvPr/>
         </p:nvSpPr>
         <p:spPr>
-          <a:xfrm rot="-150000">
-            <a:off x="762000" y="3175000"/>
-            <a:ext cx="5207000" cy="4076700"/>
+          <a:xfrm rot="-180000">
+            <a:off x="1460500" y="2984500"/>
+            <a:ext cx="3810000" cy="4330700"/>
           </a:xfrm>
           <a:prstGeom prst="rect">
             <a:avLst/>
@@ -1419,8 +1508,8 @@
           <p:nvPr/>
         </p:nvSpPr>
         <p:spPr>
-          <a:xfrm rot="-1950000">
-            <a:off x="422463" y="3166485"/>
+          <a:xfrm rot="-1980000">
+            <a:off x="1096810" y="2961201"/>
             <a:ext cx="952500" cy="279400"/>
           </a:xfrm>
           <a:prstGeom prst="rect">
@@ -1441,8 +1530,8 @@
           <p:nvPr/>
         </p:nvSpPr>
         <p:spPr>
-          <a:xfrm rot="1410000">
-            <a:off x="5206360" y="2970327"/>
+          <a:xfrm rot="1380000">
+            <a:off x="4483727" y="2796418"/>
             <a:ext cx="952500" cy="279400"/>
           </a:xfrm>
           <a:prstGeom prst="rect">
@@ -1463,9 +1552,9 @@
           <p:nvPr/>
         </p:nvSpPr>
         <p:spPr>
-          <a:xfrm rot="-150000">
-            <a:off x="869929" y="3289439"/>
-            <a:ext cx="4978400" cy="3556000"/>
+          <a:xfrm rot="-180000">
+            <a:off x="1567156" y="3099000"/>
+            <a:ext cx="3581400" cy="3810000"/>
           </a:xfrm>
           <a:prstGeom prst="rect">
             <a:avLst/>
@@ -1491,9 +1580,9 @@
           </a:stretch>
         </p:blipFill>
         <p:spPr>
-          <a:xfrm rot="-150000">
-            <a:off x="869929" y="3289439"/>
-            <a:ext cx="4978400" cy="3556000"/>
+          <a:xfrm rot="-180000">
+            <a:off x="1567156" y="3099000"/>
+            <a:ext cx="3581400" cy="3810000"/>
           </a:xfrm>
           <a:prstGeom prst="rect">
             <a:avLst/>
@@ -1507,9 +1596,9 @@
           <p:nvPr/>
         </p:nvSpPr>
         <p:spPr>
-          <a:xfrm rot="-150000">
-            <a:off x="736523" y="6868984"/>
-            <a:ext cx="5415280" cy="292100"/>
+          <a:xfrm rot="-180000">
+            <a:off x="1485329" y="6931554"/>
+            <a:ext cx="3962400" cy="292100"/>
           </a:xfrm>
           <a:prstGeom prst="rect">
             <a:avLst/>
@@ -1558,7 +1647,7 @@
         </p:blipFill>
         <p:spPr>
           <a:xfrm>
-            <a:off x="444500" y="2794000"/>
+            <a:off x="698500" y="2984500"/>
             <a:ext cx="279400" cy="279400"/>
           </a:xfrm>
           <a:prstGeom prst="rect">
@@ -1582,7 +1671,7 @@
         </p:blipFill>
         <p:spPr>
           <a:xfrm>
-            <a:off x="6096000" y="7683500"/>
+            <a:off x="5969000" y="5588000"/>
             <a:ext cx="190500" cy="190500"/>
           </a:xfrm>
           <a:prstGeom prst="rect">
@@ -1728,7 +1817,7 @@
         </p:nvSpPr>
         <p:spPr>
           <a:xfrm rot="360000">
-            <a:off x="4699645" y="2984500"/>
+            <a:off x="4737745" y="3429000"/>
             <a:ext cx="1803400" cy="425450"/>
           </a:xfrm>
           <a:prstGeom prst="roundRect">
@@ -1765,7 +1854,7 @@
         </p:blipFill>
         <p:spPr>
           <a:xfrm rot="360000">
-            <a:off x="4856234" y="3027989"/>
+            <a:off x="4894334" y="3472489"/>
             <a:ext cx="203200" cy="203200"/>
           </a:xfrm>
           <a:prstGeom prst="rect">
@@ -1781,7 +1870,7 @@
         </p:nvSpPr>
         <p:spPr>
           <a:xfrm rot="360000">
-            <a:off x="5130680" y="3088003"/>
+            <a:off x="5168780" y="3532503"/>
             <a:ext cx="1292352" cy="247650"/>
           </a:xfrm>
           <a:prstGeom prst="rect">
@@ -1823,8 +1912,8 @@
         </p:nvSpPr>
         <p:spPr>
           <a:xfrm rot="-240000">
-            <a:off x="407095" y="7048500"/>
-            <a:ext cx="2305050" cy="450850"/>
+            <a:off x="4127847" y="6191250"/>
+            <a:ext cx="2476500" cy="450850"/>
           </a:xfrm>
           <a:prstGeom prst="roundRect">
             <a:avLst>
@@ -1865,7 +1954,7 @@
         </p:blipFill>
         <p:spPr>
           <a:xfrm rot="-240000">
-            <a:off x="573660" y="7234165"/>
+            <a:off x="4295660" y="6382823"/>
             <a:ext cx="203200" cy="203200"/>
           </a:xfrm>
           <a:prstGeom prst="rect">
@@ -1881,8 +1970,8 @@
         </p:nvSpPr>
         <p:spPr>
           <a:xfrm rot="-240000">
-            <a:off x="851254" y="7140355"/>
-            <a:ext cx="1797177" cy="247650"/>
+            <a:off x="4572007" y="6283105"/>
+            <a:ext cx="1978914" cy="247650"/>
           </a:xfrm>
           <a:prstGeom prst="rect">
             <a:avLst/>
@@ -1909,6 +1998,106 @@
                 <a:ea typeface="Geist" pitchFamily="34" charset="-122"/>
                 <a:cs typeface="Geist" pitchFamily="34" charset="-120"/>
               </a:rPr>
+              <a:t>эссе · академ часть</a:t>
+            </a:r>
+            <a:endParaRPr lang="en-US" sz="1500" dirty="0"/>
+          </a:p>
+        </p:txBody>
+      </p:sp>
+      <p:sp>
+        <p:nvSpPr>
+          <p:cNvPr id="26" name="shape-25"/>
+          <p:cNvSpPr/>
+          <p:nvPr/>
+        </p:nvSpPr>
+        <p:spPr>
+          <a:xfrm rot="-300000">
+            <a:off x="280095" y="6096000"/>
+            <a:ext cx="2305050" cy="450850"/>
+          </a:xfrm>
+          <a:prstGeom prst="roundRect">
+            <a:avLst>
+              <a:gd name="adj" fmla="val 50000"/>
+            </a:avLst>
+          </a:prstGeom>
+          <a:solidFill>
+            <a:srgbClr val="FAF8F3"/>
+          </a:solidFill>
+          <a:ln w="12700">
+            <a:solidFill>
+              <a:srgbClr val="0A0A0A"/>
+            </a:solidFill>
+            <a:prstDash val="solid"/>
+          </a:ln>
+          <a:effectLst>
+            <a:outerShdw sx="100000" sy="100000" kx="0" ky="0" algn="bl" rotWithShape="0" blurRad="177800" dist="76200" dir="5400000">
+              <a:srgbClr val="000000">
+                <a:alpha val="22000"/>
+              </a:srgbClr>
+            </a:outerShdw>
+          </a:effectLst>
+        </p:spPr>
+      </p:sp>
+      <p:pic>
+        <p:nvPicPr>
+          <p:cNvPr id="27" name="svg-26" descr="preencoded.png">    </p:cNvPr>
+          <p:cNvPicPr>
+            <a:picLocks noChangeAspect="1"/>
+          </p:cNvPicPr>
+          <p:nvPr/>
+        </p:nvPicPr>
+        <p:blipFill>
+          <a:blip r:embed="rId9"/>
+          <a:stretch>
+            <a:fillRect/>
+          </a:stretch>
+        </p:blipFill>
+        <p:spPr>
+          <a:xfrm rot="-300000">
+            <a:off x="447873" y="6297090"/>
+            <a:ext cx="203200" cy="203200"/>
+          </a:xfrm>
+          <a:prstGeom prst="rect">
+            <a:avLst/>
+          </a:prstGeom>
+        </p:spPr>
+      </p:pic>
+      <p:sp>
+        <p:nvSpPr>
+          <p:cNvPr id="28" name="text-27"/>
+          <p:cNvSpPr txBox="1"/>
+          <p:nvPr/>
+        </p:nvSpPr>
+        <p:spPr>
+          <a:xfrm rot="-300000">
+            <a:off x="724063" y="6185424"/>
+            <a:ext cx="1797177" cy="247650"/>
+          </a:xfrm>
+          <a:prstGeom prst="rect">
+            <a:avLst/>
+          </a:prstGeom>
+          <a:noFill/>
+          <a:ln/>
+        </p:spPr>
+        <p:txBody>
+          <a:bodyPr wrap="square" lIns="0" tIns="0" rIns="0" bIns="0" rtlCol="0" anchor="t"/>
+          <a:lstStyle/>
+          <a:p>
+            <a:pPr algn="l" indent="0" marL="0">
+              <a:lnSpc>
+                <a:spcPts val="1800"/>
+              </a:lnSpc>
+              <a:buNone/>
+            </a:pPr>
+            <a:r>
+              <a:rPr lang="en-US" sz="1500" b="1" spc="-10" kern="0" dirty="0">
+                <a:solidFill>
+                  <a:srgbClr val="0A0A0A"/>
+                </a:solidFill>
+                <a:latin typeface="Geist" pitchFamily="34" charset="0"/>
+                <a:ea typeface="Geist" pitchFamily="34" charset="-122"/>
+                <a:cs typeface="Geist" pitchFamily="34" charset="-120"/>
+              </a:rPr>
               <a:t>&gt;99-й перцентиль</a:t>
             </a:r>
             <a:endParaRPr lang="en-US" sz="1500" dirty="0"/>
@@ -1917,13 +2106,13 @@
       </p:sp>
       <p:sp>
         <p:nvSpPr>
-          <p:cNvPr id="26" name="text-25"/>
+          <p:cNvPr id="29" name="text-28"/>
           <p:cNvSpPr txBox="1"/>
           <p:nvPr/>
         </p:nvSpPr>
         <p:spPr>
           <a:xfrm rot="-180000">
-            <a:off x="4064149" y="7301309"/>
+            <a:off x="3556149" y="7301309"/>
             <a:ext cx="1972183" cy="514350"/>
           </a:xfrm>
           <a:prstGeom prst="rect">
@@ -2145,7 +2334,7 @@
                 <a:ea typeface="IBM Plex Mono" pitchFamily="34" charset="-122"/>
                 <a:cs typeface="IBM Plex Mono" pitchFamily="34" charset="-120"/>
               </a:rPr>
-              <a:t>02 / 04</a:t>
+              <a:t>02 / 05</a:t>
             </a:r>
             <a:endParaRPr lang="en-US" sz="1000" dirty="0"/>
           </a:p>
@@ -2962,8 +3151,8 @@
         </p:nvSpPr>
         <p:spPr>
           <a:xfrm>
-            <a:off x="456605" y="406400"/>
-            <a:ext cx="1962150" cy="323850"/>
+            <a:off x="457845" y="406400"/>
+            <a:ext cx="1771650" cy="323850"/>
           </a:xfrm>
           <a:prstGeom prst="roundRect">
             <a:avLst>
@@ -3013,8 +3202,8 @@
         </p:nvSpPr>
         <p:spPr>
           <a:xfrm>
-            <a:off x="786805" y="482600"/>
-            <a:ext cx="1595247" cy="171450"/>
+            <a:off x="788045" y="482600"/>
+            <a:ext cx="1393317" cy="171450"/>
           </a:xfrm>
           <a:prstGeom prst="rect">
             <a:avLst/>
@@ -3041,7 +3230,7 @@
                 <a:ea typeface="IBM Plex Mono" pitchFamily="34" charset="-122"/>
                 <a:cs typeface="IBM Plex Mono" pitchFamily="34" charset="-120"/>
               </a:rPr>
-              <a:t>МАРТ–МАЙ · УРОКИ</a:t>
+              <a:t>ЛЕТО · ФРАНЦИЯ</a:t>
             </a:r>
             <a:endParaRPr lang="en-US" sz="1000" dirty="0"/>
           </a:p>
@@ -3083,7 +3272,7 @@
                 <a:ea typeface="IBM Plex Mono" pitchFamily="34" charset="-122"/>
                 <a:cs typeface="IBM Plex Mono" pitchFamily="34" charset="-120"/>
               </a:rPr>
-              <a:t>03 / 04</a:t>
+              <a:t>03 / 05</a:t>
             </a:r>
             <a:endParaRPr lang="en-US" sz="1000" dirty="0"/>
           </a:p>
@@ -3125,7 +3314,7 @@
                 <a:ea typeface="Geist" pitchFamily="34" charset="-122"/>
                 <a:cs typeface="Geist" pitchFamily="34" charset="-120"/>
               </a:rPr>
-              <a:t>Как это </a:t>
+              <a:t>Открыли </a:t>
             </a:r>
             <a:pPr algn="l" indent="0" marL="0">
               <a:lnSpc>
@@ -3142,7 +3331,7 @@
                 <a:ea typeface="Noto Serif Display Light" pitchFamily="34" charset="-122"/>
                 <a:cs typeface="Noto Serif Display Light" pitchFamily="34" charset="-120"/>
               </a:rPr>
-              <a:t>было</a:t>
+              <a:t>вместе</a:t>
             </a:r>
             <a:endParaRPr lang="en-US" sz="4600" dirty="0"/>
           </a:p>
@@ -3156,8 +3345,8 @@
         </p:nvSpPr>
         <p:spPr>
           <a:xfrm>
-            <a:off x="457200" y="1816695"/>
-            <a:ext cx="6300216" cy="603250"/>
+            <a:off x="457002" y="1752600"/>
+            <a:ext cx="6158865" cy="533400"/>
           </a:xfrm>
           <a:prstGeom prst="rect">
             <a:avLst/>
@@ -3171,12 +3360,12 @@
           <a:p>
             <a:pPr algn="l" indent="0" marL="0">
               <a:lnSpc>
-                <a:spcPts val="2380"/>
-              </a:lnSpc>
-              <a:buNone/>
-            </a:pPr>
-            <a:r>
-              <a:rPr lang="en-US" sz="1700" dirty="0">
+                <a:spcPts val="2100"/>
+              </a:lnSpc>
+              <a:buNone/>
+            </a:pPr>
+            <a:r>
+              <a:rPr lang="en-US" sz="1500" dirty="0">
                 <a:solidFill>
                   <a:srgbClr val="2B2A27"/>
                 </a:solidFill>
@@ -3184,121 +3373,30 @@
                 <a:ea typeface="Geist" pitchFamily="34" charset="-122"/>
                 <a:cs typeface="Geist" pitchFamily="34" charset="-120"/>
               </a:rPr>
-              <a:t>В январе Юсуф написал пробник на 1300. В марте мы начали заниматься, до экзамена оставалось три месяца.</a:t>
-            </a:r>
-            <a:endParaRPr lang="en-US" sz="1700" dirty="0"/>
-          </a:p>
-        </p:txBody>
-      </p:sp>
-      <p:sp>
-        <p:nvSpPr>
-          <p:cNvPr id="8" name="text-7"/>
-          <p:cNvSpPr txBox="1"/>
-          <p:nvPr/>
-        </p:nvSpPr>
-        <p:spPr>
-          <a:xfrm>
-            <a:off x="457200" y="2535436"/>
-            <a:ext cx="6300216" cy="603250"/>
-          </a:xfrm>
-          <a:prstGeom prst="rect">
-            <a:avLst/>
-          </a:prstGeom>
-          <a:noFill/>
-          <a:ln/>
-        </p:spPr>
-        <p:txBody>
-          <a:bodyPr wrap="square" lIns="0" tIns="0" rIns="0" bIns="0" rtlCol="0" anchor="t"/>
-          <a:lstStyle/>
-          <a:p>
-            <a:pPr algn="l" indent="0" marL="0">
-              <a:lnSpc>
-                <a:spcPts val="2380"/>
-              </a:lnSpc>
-              <a:buNone/>
-            </a:pPr>
-            <a:r>
-              <a:rPr lang="en-US" sz="1700" dirty="0">
-                <a:solidFill>
-                  <a:srgbClr val="2B2A27"/>
-                </a:solidFill>
-                <a:latin typeface="Geist" pitchFamily="34" charset="0"/>
-                <a:ea typeface="Geist" pitchFamily="34" charset="-122"/>
-                <a:cs typeface="Geist" pitchFamily="34" charset="-120"/>
-              </a:rPr>
-              <a:t>Занимались в основном Verbal, немного Math. Ещё больше он работал сам, каждый день.</a:t>
-            </a:r>
-            <a:endParaRPr lang="en-US" sz="1700" dirty="0"/>
-          </a:p>
-        </p:txBody>
-      </p:sp>
-      <p:sp>
-        <p:nvSpPr>
-          <p:cNvPr id="9" name="text-8"/>
-          <p:cNvSpPr txBox="1"/>
-          <p:nvPr/>
-        </p:nvSpPr>
-        <p:spPr>
-          <a:xfrm>
-            <a:off x="457200" y="3254177"/>
-            <a:ext cx="6300216" cy="603250"/>
-          </a:xfrm>
-          <a:prstGeom prst="rect">
-            <a:avLst/>
-          </a:prstGeom>
-          <a:noFill/>
-          <a:ln/>
-        </p:spPr>
-        <p:txBody>
-          <a:bodyPr wrap="square" lIns="0" tIns="0" rIns="0" bIns="0" rtlCol="0" anchor="t"/>
-          <a:lstStyle/>
-          <a:p>
-            <a:pPr algn="l" indent="0" marL="0">
-              <a:lnSpc>
-                <a:spcPts val="2380"/>
-              </a:lnSpc>
-              <a:buNone/>
-            </a:pPr>
-            <a:r>
-              <a:rPr lang="en-US" sz="1700" dirty="0">
-                <a:solidFill>
-                  <a:srgbClr val="2B2A27"/>
-                </a:solidFill>
-                <a:latin typeface="Geist" pitchFamily="34" charset="0"/>
-                <a:ea typeface="Geist" pitchFamily="34" charset="-122"/>
-                <a:cs typeface="Geist" pitchFamily="34" charset="-120"/>
-              </a:rPr>
-              <a:t>1580 это его труд. Я рад, что был рядом. С прошлого года я помогаю ему и с поступлением в университеты.</a:t>
-            </a:r>
-            <a:endParaRPr lang="en-US" sz="1700" dirty="0"/>
-          </a:p>
-        </p:txBody>
-      </p:sp>
-      <p:sp>
-        <p:nvSpPr>
-          <p:cNvPr id="10" name="shape-9"/>
+              <a:t>Летом Юсуф поехал на международный конкурс во Францию. Там мы вместе и открыли его результат.</a:t>
+            </a:r>
+            <a:endParaRPr lang="en-US" sz="1500" dirty="0"/>
+          </a:p>
+        </p:txBody>
+      </p:sp>
+      <p:sp>
+        <p:nvSpPr>
+          <p:cNvPr id="8" name="shape-7"/>
           <p:cNvSpPr/>
           <p:nvPr/>
         </p:nvSpPr>
         <p:spPr>
-          <a:xfrm rot="-180000">
-            <a:off x="455811" y="4699000"/>
-            <a:ext cx="2736850" cy="450850"/>
-          </a:xfrm>
-          <a:prstGeom prst="roundRect">
-            <a:avLst>
-              <a:gd name="adj" fmla="val 50000"/>
-            </a:avLst>
+          <a:xfrm rot="120000">
+            <a:off x="698500" y="2984500"/>
+            <a:ext cx="5207000" cy="4076700"/>
+          </a:xfrm>
+          <a:prstGeom prst="rect">
+            <a:avLst/>
           </a:prstGeom>
           <a:solidFill>
-            <a:srgbClr val="FAF8F3"/>
+            <a:srgbClr val="FFFFFF"/>
           </a:solidFill>
-          <a:ln w="12700">
-            <a:solidFill>
-              <a:srgbClr val="0A0A0A"/>
-            </a:solidFill>
-            <a:prstDash val="solid"/>
-          </a:ln>
+          <a:ln/>
           <a:effectLst>
             <a:outerShdw sx="100000" sy="100000" kx="0" ky="0" algn="bl" rotWithShape="0" blurRad="177800" dist="76200" dir="5400000">
               <a:srgbClr val="000000">
@@ -3308,9 +3406,73 @@
           </a:effectLst>
         </p:spPr>
       </p:sp>
+      <p:sp>
+        <p:nvSpPr>
+          <p:cNvPr id="9" name="shape-8"/>
+          <p:cNvSpPr/>
+          <p:nvPr/>
+        </p:nvSpPr>
+        <p:spPr>
+          <a:xfrm rot="-1680000">
+            <a:off x="516201" y="2788322"/>
+            <a:ext cx="952500" cy="279400"/>
+          </a:xfrm>
+          <a:prstGeom prst="rect">
+            <a:avLst/>
+          </a:prstGeom>
+          <a:solidFill>
+            <a:srgbClr val="D5D5D4">
+              <a:alpha val="90000"/>
+            </a:srgbClr>
+          </a:solidFill>
+          <a:ln/>
+        </p:spPr>
+      </p:sp>
+      <p:sp>
+        <p:nvSpPr>
+          <p:cNvPr id="10" name="shape-9"/>
+          <p:cNvSpPr/>
+          <p:nvPr/>
+        </p:nvSpPr>
+        <p:spPr>
+          <a:xfrm rot="1680000">
+            <a:off x="5300742" y="2968109"/>
+            <a:ext cx="952500" cy="279400"/>
+          </a:xfrm>
+          <a:prstGeom prst="rect">
+            <a:avLst/>
+          </a:prstGeom>
+          <a:solidFill>
+            <a:srgbClr val="D5D5D4">
+              <a:alpha val="90000"/>
+            </a:srgbClr>
+          </a:solidFill>
+          <a:ln/>
+        </p:spPr>
+      </p:sp>
+      <p:sp>
+        <p:nvSpPr>
+          <p:cNvPr id="11" name="shape-10"/>
+          <p:cNvSpPr/>
+          <p:nvPr/>
+        </p:nvSpPr>
+        <p:spPr>
+          <a:xfrm rot="120000">
+            <a:off x="817897" y="3098889"/>
+            <a:ext cx="4978400" cy="3556000"/>
+          </a:xfrm>
+          <a:prstGeom prst="rect">
+            <a:avLst/>
+          </a:prstGeom>
+          <a:solidFill>
+            <a:srgbClr val="D5D5D4"/>
+          </a:solidFill>
+          <a:ln/>
+        </p:spPr>
+      </p:sp>
       <p:pic>
         <p:nvPicPr>
-          <p:cNvPr id="11" name="svg-10" descr="preencoded.png">    </p:cNvPr>
+          <p:cNvPr id="12" name="img-11" descr="preencoded.png">    </p:cNvPr>
           <p:cNvPicPr>
             <a:picLocks noChangeAspect="1"/>
           </p:cNvPicPr>
@@ -3323,9 +3485,9 @@
           </a:stretch>
         </p:blipFill>
         <p:spPr>
-          <a:xfrm rot="-180000">
-            <a:off x="623808" y="4880412"/>
-            <a:ext cx="203200" cy="203200"/>
+          <a:xfrm rot="120000">
+            <a:off x="817897" y="3098889"/>
+            <a:ext cx="4978400" cy="3556000"/>
           </a:xfrm>
           <a:prstGeom prst="rect">
             <a:avLst/>
@@ -3334,14 +3496,14 @@
       </p:pic>
       <p:sp>
         <p:nvSpPr>
-          <p:cNvPr id="12" name="text-11"/>
+          <p:cNvPr id="13" name="text-12"/>
           <p:cNvSpPr txBox="1"/>
           <p:nvPr/>
         </p:nvSpPr>
         <p:spPr>
-          <a:xfrm rot="-180000">
-            <a:off x="900119" y="4793289"/>
-            <a:ext cx="2254885" cy="247650"/>
+          <a:xfrm rot="120000">
+            <a:off x="531422" y="6679102"/>
+            <a:ext cx="5415280" cy="292100"/>
           </a:xfrm>
           <a:prstGeom prst="rect">
             <a:avLst/>
@@ -3353,37 +3515,127 @@
           <a:bodyPr wrap="square" lIns="0" tIns="0" rIns="0" bIns="0" rtlCol="0" anchor="t"/>
           <a:lstStyle/>
           <a:p>
+            <a:pPr algn="ctr" indent="0" marL="0">
+              <a:lnSpc>
+                <a:spcPts val="2040"/>
+              </a:lnSpc>
+              <a:buNone/>
+            </a:pPr>
+            <a:r>
+              <a:rPr lang="en-US" sz="1700" i="1" dirty="0">
+                <a:solidFill>
+                  <a:srgbClr val="0A0A0A"/>
+                </a:solidFill>
+                <a:latin typeface="Noto Serif Display Light" pitchFamily="34" charset="0"/>
+                <a:ea typeface="Noto Serif Display Light" pitchFamily="34" charset="-122"/>
+                <a:cs typeface="Noto Serif Display Light" pitchFamily="34" charset="-120"/>
+              </a:rPr>
+              <a:t>Франция, лето 2026</a:t>
+            </a:r>
+            <a:endParaRPr lang="en-US" sz="1700" dirty="0"/>
+          </a:p>
+        </p:txBody>
+      </p:sp>
+      <p:pic>
+        <p:nvPicPr>
+          <p:cNvPr id="14" name="svg-13" descr="preencoded.png">    </p:cNvPr>
+          <p:cNvPicPr>
+            <a:picLocks noChangeAspect="1"/>
+          </p:cNvPicPr>
+          <p:nvPr/>
+        </p:nvPicPr>
+        <p:blipFill>
+          <a:blip r:embed="rId4"/>
+          <a:stretch>
+            <a:fillRect/>
+          </a:stretch>
+        </p:blipFill>
+        <p:spPr>
+          <a:xfrm>
+            <a:off x="5207000" y="7112000"/>
+            <a:ext cx="279400" cy="279400"/>
+          </a:xfrm>
+          <a:prstGeom prst="rect">
+            <a:avLst/>
+          </a:prstGeom>
+        </p:spPr>
+      </p:pic>
+      <p:pic>
+        <p:nvPicPr>
+          <p:cNvPr id="15" name="svg-14" descr="preencoded.png">    </p:cNvPr>
+          <p:cNvPicPr>
+            <a:picLocks noChangeAspect="1"/>
+          </p:cNvPicPr>
+          <p:nvPr/>
+        </p:nvPicPr>
+        <p:blipFill>
+          <a:blip r:embed="rId5"/>
+          <a:stretch>
+            <a:fillRect/>
+          </a:stretch>
+        </p:blipFill>
+        <p:spPr>
+          <a:xfrm>
+            <a:off x="444500" y="2730500"/>
+            <a:ext cx="190500" cy="190500"/>
+          </a:xfrm>
+          <a:prstGeom prst="rect">
+            <a:avLst/>
+          </a:prstGeom>
+        </p:spPr>
+      </p:pic>
+      <p:sp>
+        <p:nvSpPr>
+          <p:cNvPr id="16" name="text-15"/>
+          <p:cNvSpPr txBox="1"/>
+          <p:nvPr/>
+        </p:nvSpPr>
+        <p:spPr>
+          <a:xfrm>
+            <a:off x="457845" y="7969250"/>
+            <a:ext cx="895223" cy="171450"/>
+          </a:xfrm>
+          <a:prstGeom prst="rect">
+            <a:avLst/>
+          </a:prstGeom>
+          <a:noFill/>
+          <a:ln/>
+        </p:spPr>
+        <p:txBody>
+          <a:bodyPr wrap="square" lIns="0" tIns="0" rIns="0" bIns="0" rtlCol="0" anchor="t"/>
+          <a:lstStyle/>
+          <a:p>
             <a:pPr algn="l" indent="0" marL="0">
               <a:lnSpc>
-                <a:spcPts val="1800"/>
-              </a:lnSpc>
-              <a:buNone/>
-            </a:pPr>
-            <a:r>
-              <a:rPr lang="en-US" sz="1500" b="1" spc="-10" kern="0" dirty="0">
+                <a:spcPts val="1200"/>
+              </a:lnSpc>
+              <a:buNone/>
+            </a:pPr>
+            <a:r>
+              <a:rPr lang="en-US" sz="1000" spc="140" kern="0" dirty="0">
                 <a:solidFill>
                   <a:srgbClr val="0A0A0A"/>
                 </a:solidFill>
-                <a:latin typeface="Geist" pitchFamily="34" charset="0"/>
-                <a:ea typeface="Geist" pitchFamily="34" charset="-122"/>
-                <a:cs typeface="Geist" pitchFamily="34" charset="-120"/>
-              </a:rPr>
-              <a:t>январь · пробник 1300</a:t>
-            </a:r>
-            <a:endParaRPr lang="en-US" sz="1500" dirty="0"/>
-          </a:p>
-        </p:txBody>
-      </p:sp>
-      <p:sp>
-        <p:nvSpPr>
-          <p:cNvPr id="13" name="shape-12"/>
+                <a:latin typeface="IBM Plex Mono" pitchFamily="34" charset="0"/>
+                <a:ea typeface="IBM Plex Mono" pitchFamily="34" charset="-122"/>
+                <a:cs typeface="IBM Plex Mono" pitchFamily="34" charset="-120"/>
+              </a:rPr>
+              <a:t>@NURZYCOM</a:t>
+            </a:r>
+            <a:endParaRPr lang="en-US" sz="1000" dirty="0"/>
+          </a:p>
+        </p:txBody>
+      </p:sp>
+      <p:sp>
+        <p:nvSpPr>
+          <p:cNvPr id="17" name="shape-16"/>
           <p:cNvSpPr/>
           <p:nvPr/>
         </p:nvSpPr>
         <p:spPr>
-          <a:xfrm rot="120000">
-            <a:off x="1408509" y="5289550"/>
-            <a:ext cx="2247900" cy="450850"/>
+          <a:xfrm>
+            <a:off x="5340945" y="7893050"/>
+            <a:ext cx="1060450" cy="323850"/>
           </a:xfrm>
           <a:prstGeom prst="roundRect">
             <a:avLst>
@@ -3391,14 +3643,97 @@
             </a:avLst>
           </a:prstGeom>
           <a:solidFill>
-            <a:srgbClr val="FAF8F3"/>
+            <a:srgbClr val="0A0A0A"/>
           </a:solidFill>
-          <a:ln w="12700">
-            <a:solidFill>
-              <a:srgbClr val="0A0A0A"/>
-            </a:solidFill>
-            <a:prstDash val="solid"/>
-          </a:ln>
+          <a:ln/>
+        </p:spPr>
+      </p:sp>
+      <p:sp>
+        <p:nvSpPr>
+          <p:cNvPr id="18" name="text-17"/>
+          <p:cNvSpPr txBox="1"/>
+          <p:nvPr/>
+        </p:nvSpPr>
+        <p:spPr>
+          <a:xfrm>
+            <a:off x="5480645" y="7969250"/>
+            <a:ext cx="599059" cy="171450"/>
+          </a:xfrm>
+          <a:prstGeom prst="rect">
+            <a:avLst/>
+          </a:prstGeom>
+          <a:noFill/>
+          <a:ln/>
+        </p:spPr>
+        <p:txBody>
+          <a:bodyPr wrap="square" lIns="0" tIns="0" rIns="0" bIns="0" rtlCol="0" anchor="t"/>
+          <a:lstStyle/>
+          <a:p>
+            <a:pPr algn="l" indent="0" marL="0">
+              <a:lnSpc>
+                <a:spcPts val="1200"/>
+              </a:lnSpc>
+              <a:buNone/>
+            </a:pPr>
+            <a:r>
+              <a:rPr lang="en-US" sz="1000" spc="140" kern="0" dirty="0">
+                <a:solidFill>
+                  <a:srgbClr val="FAF8F3"/>
+                </a:solidFill>
+                <a:latin typeface="IBM Plex Mono" pitchFamily="34" charset="0"/>
+                <a:ea typeface="IBM Plex Mono" pitchFamily="34" charset="-122"/>
+                <a:cs typeface="IBM Plex Mono" pitchFamily="34" charset="-120"/>
+              </a:rPr>
+              <a:t>ЛИСТАЙ</a:t>
+            </a:r>
+            <a:endParaRPr lang="en-US" sz="1000" dirty="0"/>
+          </a:p>
+        </p:txBody>
+      </p:sp>
+      <p:pic>
+        <p:nvPicPr>
+          <p:cNvPr id="19" name="svg-18" descr="preencoded.png">    </p:cNvPr>
+          <p:cNvPicPr>
+            <a:picLocks noChangeAspect="1"/>
+          </p:cNvPicPr>
+          <p:nvPr/>
+        </p:nvPicPr>
+        <p:blipFill>
+          <a:blip r:embed="rId6"/>
+          <a:stretch>
+            <a:fillRect/>
+          </a:stretch>
+        </p:blipFill>
+        <p:spPr>
+          <a:xfrm>
+            <a:off x="6121400" y="7985125"/>
+            <a:ext cx="139700" cy="139700"/>
+          </a:xfrm>
+          <a:prstGeom prst="rect">
+            <a:avLst/>
+          </a:prstGeom>
+        </p:spPr>
+      </p:pic>
+      <p:sp>
+        <p:nvSpPr>
+          <p:cNvPr id="20" name="shape-19"/>
+          <p:cNvSpPr/>
+          <p:nvPr/>
+        </p:nvSpPr>
+        <p:spPr>
+          <a:xfrm rot="-360000">
+            <a:off x="5036741" y="2794000"/>
+            <a:ext cx="1441450" cy="425450"/>
+          </a:xfrm>
+          <a:prstGeom prst="roundRect">
+            <a:avLst>
+              <a:gd name="adj" fmla="val 50000"/>
+            </a:avLst>
+          </a:prstGeom>
+          <a:solidFill>
+            <a:srgbClr val="0A0A0A"/>
+          </a:solidFill>
+          <a:ln/>
           <a:effectLst>
             <a:outerShdw sx="100000" sy="100000" kx="0" ky="0" algn="bl" rotWithShape="0" blurRad="177800" dist="76200" dir="5400000">
               <a:srgbClr val="000000">
@@ -3410,192 +3745,7 @@
       </p:sp>
       <p:pic>
         <p:nvPicPr>
-          <p:cNvPr id="14" name="svg-13" descr="preencoded.png">    </p:cNvPr>
-          <p:cNvPicPr>
-            <a:picLocks noChangeAspect="1"/>
-          </p:cNvPicPr>
-          <p:nvPr/>
-        </p:nvPicPr>
-        <p:blipFill>
-          <a:blip r:embed="rId4"/>
-          <a:stretch>
-            <a:fillRect/>
-          </a:stretch>
-        </p:blipFill>
-        <p:spPr>
-          <a:xfrm rot="120000">
-            <a:off x="1575321" y="5383499"/>
-            <a:ext cx="203200" cy="203200"/>
-          </a:xfrm>
-          <a:prstGeom prst="rect">
-            <a:avLst/>
-          </a:prstGeom>
-        </p:spPr>
-      </p:pic>
-      <p:sp>
-        <p:nvSpPr>
-          <p:cNvPr id="15" name="text-14"/>
-          <p:cNvSpPr txBox="1"/>
-          <p:nvPr/>
-        </p:nvSpPr>
-        <p:spPr>
-          <a:xfrm rot="120000">
-            <a:off x="1852924" y="5396025"/>
-            <a:ext cx="1736598" cy="247650"/>
-          </a:xfrm>
-          <a:prstGeom prst="rect">
-            <a:avLst/>
-          </a:prstGeom>
-          <a:noFill/>
-          <a:ln/>
-        </p:spPr>
-        <p:txBody>
-          <a:bodyPr wrap="square" lIns="0" tIns="0" rIns="0" bIns="0" rtlCol="0" anchor="t"/>
-          <a:lstStyle/>
-          <a:p>
-            <a:pPr algn="l" indent="0" marL="0">
-              <a:lnSpc>
-                <a:spcPts val="1800"/>
-              </a:lnSpc>
-              <a:buNone/>
-            </a:pPr>
-            <a:r>
-              <a:rPr lang="en-US" sz="1500" b="1" spc="-10" kern="0" dirty="0">
-                <a:solidFill>
-                  <a:srgbClr val="0A0A0A"/>
-                </a:solidFill>
-                <a:latin typeface="Geist" pitchFamily="34" charset="0"/>
-                <a:ea typeface="Geist" pitchFamily="34" charset="-122"/>
-                <a:cs typeface="Geist" pitchFamily="34" charset="-120"/>
-              </a:rPr>
-              <a:t>март–май · уроки</a:t>
-            </a:r>
-            <a:endParaRPr lang="en-US" sz="1500" dirty="0"/>
-          </a:p>
-        </p:txBody>
-      </p:sp>
-      <p:sp>
-        <p:nvSpPr>
-          <p:cNvPr id="16" name="shape-15"/>
-          <p:cNvSpPr/>
-          <p:nvPr/>
-        </p:nvSpPr>
-        <p:spPr>
-          <a:xfrm rot="-120000">
-            <a:off x="2362002" y="5880100"/>
-            <a:ext cx="2228850" cy="425450"/>
-          </a:xfrm>
-          <a:prstGeom prst="roundRect">
-            <a:avLst>
-              <a:gd name="adj" fmla="val 50000"/>
-            </a:avLst>
-          </a:prstGeom>
-          <a:solidFill>
-            <a:srgbClr val="0A0A0A"/>
-          </a:solidFill>
-          <a:ln/>
-          <a:effectLst>
-            <a:outerShdw sx="100000" sy="100000" kx="0" ky="0" algn="bl" rotWithShape="0" blurRad="177800" dist="76200" dir="5400000">
-              <a:srgbClr val="000000">
-                <a:alpha val="22000"/>
-              </a:srgbClr>
-            </a:outerShdw>
-          </a:effectLst>
-        </p:spPr>
-      </p:sp>
-      <p:pic>
-        <p:nvPicPr>
-          <p:cNvPr id="17" name="svg-16" descr="preencoded.png">    </p:cNvPr>
-          <p:cNvPicPr>
-            <a:picLocks noChangeAspect="1"/>
-          </p:cNvPicPr>
-          <p:nvPr/>
-        </p:nvPicPr>
-        <p:blipFill>
-          <a:blip r:embed="rId5"/>
-          <a:stretch>
-            <a:fillRect/>
-          </a:stretch>
-        </p:blipFill>
-        <p:spPr>
-          <a:xfrm rot="-120000">
-            <a:off x="2515124" y="6021246"/>
-            <a:ext cx="203200" cy="203200"/>
-          </a:xfrm>
-          <a:prstGeom prst="rect">
-            <a:avLst/>
-          </a:prstGeom>
-        </p:spPr>
-      </p:pic>
-      <p:sp>
-        <p:nvSpPr>
-          <p:cNvPr id="18" name="text-17"/>
-          <p:cNvSpPr txBox="1"/>
-          <p:nvPr/>
-        </p:nvSpPr>
-        <p:spPr>
-          <a:xfrm rot="-120000">
-            <a:off x="2793716" y="5964125"/>
-            <a:ext cx="1743329" cy="247650"/>
-          </a:xfrm>
-          <a:prstGeom prst="rect">
-            <a:avLst/>
-          </a:prstGeom>
-          <a:noFill/>
-          <a:ln/>
-        </p:spPr>
-        <p:txBody>
-          <a:bodyPr wrap="square" lIns="0" tIns="0" rIns="0" bIns="0" rtlCol="0" anchor="t"/>
-          <a:lstStyle/>
-          <a:p>
-            <a:pPr algn="l" indent="0" marL="0">
-              <a:lnSpc>
-                <a:spcPts val="1800"/>
-              </a:lnSpc>
-              <a:buNone/>
-            </a:pPr>
-            <a:r>
-              <a:rPr lang="en-US" sz="1500" b="1" spc="-10" kern="0" dirty="0">
-                <a:solidFill>
-                  <a:srgbClr val="FAF8F3"/>
-                </a:solidFill>
-                <a:latin typeface="Geist" pitchFamily="34" charset="0"/>
-                <a:ea typeface="Geist" pitchFamily="34" charset="-122"/>
-                <a:cs typeface="Geist" pitchFamily="34" charset="-120"/>
-              </a:rPr>
-              <a:t>6 июня · SAT 1580</a:t>
-            </a:r>
-            <a:endParaRPr lang="en-US" sz="1500" dirty="0"/>
-          </a:p>
-        </p:txBody>
-      </p:sp>
-      <p:pic>
-        <p:nvPicPr>
-          <p:cNvPr id="19" name="svg-18" descr="preencoded.png">    </p:cNvPr>
-          <p:cNvPicPr>
-            <a:picLocks noChangeAspect="1"/>
-          </p:cNvPicPr>
-          <p:nvPr/>
-        </p:nvPicPr>
-        <p:blipFill>
-          <a:blip r:embed="rId6"/>
-          <a:stretch>
-            <a:fillRect/>
-          </a:stretch>
-        </p:blipFill>
-        <p:spPr>
-          <a:xfrm>
-            <a:off x="5689600" y="4826000"/>
-            <a:ext cx="279400" cy="279400"/>
-          </a:xfrm>
-          <a:prstGeom prst="rect">
-            <a:avLst/>
-          </a:prstGeom>
-        </p:spPr>
-      </p:pic>
-      <p:pic>
-        <p:nvPicPr>
-          <p:cNvPr id="20" name="svg-19" descr="preencoded.png">    </p:cNvPr>
+          <p:cNvPr id="21" name="svg-20" descr="preencoded.png">    </p:cNvPr>
           <p:cNvPicPr>
             <a:picLocks noChangeAspect="1"/>
           </p:cNvPicPr>
@@ -3608,9 +3758,9 @@
           </a:stretch>
         </p:blipFill>
         <p:spPr>
-          <a:xfrm>
-            <a:off x="5461000" y="6985000"/>
-            <a:ext cx="190500" cy="190500"/>
+          <a:xfrm rot="-360000">
+            <a:off x="5192881" y="2953787"/>
+            <a:ext cx="203200" cy="203200"/>
           </a:xfrm>
           <a:prstGeom prst="rect">
             <a:avLst/>
@@ -3619,14 +3769,14 @@
       </p:pic>
       <p:sp>
         <p:nvSpPr>
-          <p:cNvPr id="21" name="text-20"/>
+          <p:cNvPr id="22" name="text-21"/>
           <p:cNvSpPr txBox="1"/>
           <p:nvPr/>
         </p:nvSpPr>
         <p:spPr>
-          <a:xfrm>
-            <a:off x="457845" y="7969250"/>
-            <a:ext cx="895223" cy="171450"/>
+          <a:xfrm rot="-360000">
+            <a:off x="5467775" y="2868297"/>
+            <a:ext cx="908685" cy="247650"/>
           </a:xfrm>
           <a:prstGeom prst="rect">
             <a:avLst/>
@@ -3640,46 +3790,24 @@
           <a:p>
             <a:pPr algn="l" indent="0" marL="0">
               <a:lnSpc>
-                <a:spcPts val="1200"/>
-              </a:lnSpc>
-              <a:buNone/>
-            </a:pPr>
-            <a:r>
-              <a:rPr lang="en-US" sz="1000" spc="140" kern="0" dirty="0">
-                <a:solidFill>
-                  <a:srgbClr val="0A0A0A"/>
-                </a:solidFill>
-                <a:latin typeface="IBM Plex Mono" pitchFamily="34" charset="0"/>
-                <a:ea typeface="IBM Plex Mono" pitchFamily="34" charset="-122"/>
-                <a:cs typeface="IBM Plex Mono" pitchFamily="34" charset="-120"/>
-              </a:rPr>
-              <a:t>@NURZYCOM</a:t>
-            </a:r>
-            <a:endParaRPr lang="en-US" sz="1000" dirty="0"/>
-          </a:p>
-        </p:txBody>
-      </p:sp>
-      <p:sp>
-        <p:nvSpPr>
-          <p:cNvPr id="22" name="shape-21"/>
-          <p:cNvSpPr/>
-          <p:nvPr/>
-        </p:nvSpPr>
-        <p:spPr>
-          <a:xfrm>
-            <a:off x="5340945" y="7893050"/>
-            <a:ext cx="1060450" cy="323850"/>
-          </a:xfrm>
-          <a:prstGeom prst="roundRect">
-            <a:avLst>
-              <a:gd name="adj" fmla="val 50000"/>
-            </a:avLst>
-          </a:prstGeom>
-          <a:solidFill>
-            <a:srgbClr val="0A0A0A"/>
-          </a:solidFill>
-          <a:ln/>
-        </p:spPr>
+                <a:spcPts val="1800"/>
+              </a:lnSpc>
+              <a:buNone/>
+            </a:pPr>
+            <a:r>
+              <a:rPr lang="en-US" sz="1500" b="1" spc="-10" kern="0" dirty="0">
+                <a:solidFill>
+                  <a:srgbClr val="FAF8F3"/>
+                </a:solidFill>
+                <a:latin typeface="Geist" pitchFamily="34" charset="0"/>
+                <a:ea typeface="Geist" pitchFamily="34" charset="-122"/>
+                <a:cs typeface="Geist" pitchFamily="34" charset="-120"/>
+              </a:rPr>
+              <a:t>SAT 1580</a:t>
+            </a:r>
+            <a:endParaRPr lang="en-US" sz="1500" dirty="0"/>
+          </a:p>
+        </p:txBody>
       </p:sp>
       <p:sp>
         <p:nvSpPr>
@@ -3688,75 +3816,9 @@
           <p:nvPr/>
         </p:nvSpPr>
         <p:spPr>
-          <a:xfrm>
-            <a:off x="5480645" y="7969250"/>
-            <a:ext cx="599059" cy="171450"/>
-          </a:xfrm>
-          <a:prstGeom prst="rect">
-            <a:avLst/>
-          </a:prstGeom>
-          <a:noFill/>
-          <a:ln/>
-        </p:spPr>
-        <p:txBody>
-          <a:bodyPr wrap="square" lIns="0" tIns="0" rIns="0" bIns="0" rtlCol="0" anchor="t"/>
-          <a:lstStyle/>
-          <a:p>
-            <a:pPr algn="l" indent="0" marL="0">
-              <a:lnSpc>
-                <a:spcPts val="1200"/>
-              </a:lnSpc>
-              <a:buNone/>
-            </a:pPr>
-            <a:r>
-              <a:rPr lang="en-US" sz="1000" spc="140" kern="0" dirty="0">
-                <a:solidFill>
-                  <a:srgbClr val="FAF8F3"/>
-                </a:solidFill>
-                <a:latin typeface="IBM Plex Mono" pitchFamily="34" charset="0"/>
-                <a:ea typeface="IBM Plex Mono" pitchFamily="34" charset="-122"/>
-                <a:cs typeface="IBM Plex Mono" pitchFamily="34" charset="-120"/>
-              </a:rPr>
-              <a:t>ЛИСТАЙ</a:t>
-            </a:r>
-            <a:endParaRPr lang="en-US" sz="1000" dirty="0"/>
-          </a:p>
-        </p:txBody>
-      </p:sp>
-      <p:pic>
-        <p:nvPicPr>
-          <p:cNvPr id="24" name="svg-23" descr="preencoded.png">    </p:cNvPr>
-          <p:cNvPicPr>
-            <a:picLocks noChangeAspect="1"/>
-          </p:cNvPicPr>
-          <p:nvPr/>
-        </p:nvPicPr>
-        <p:blipFill>
-          <a:blip r:embed="rId8"/>
-          <a:stretch>
-            <a:fillRect/>
-          </a:stretch>
-        </p:blipFill>
-        <p:spPr>
-          <a:xfrm>
-            <a:off x="6121400" y="7985125"/>
-            <a:ext cx="139700" cy="139700"/>
-          </a:xfrm>
-          <a:prstGeom prst="rect">
-            <a:avLst/>
-          </a:prstGeom>
-        </p:spPr>
-      </p:pic>
-      <p:sp>
-        <p:nvSpPr>
-          <p:cNvPr id="25" name="text-24"/>
-          <p:cNvSpPr txBox="1"/>
-          <p:nvPr/>
-        </p:nvSpPr>
-        <p:spPr>
           <a:xfrm rot="-180000">
-            <a:off x="2096046" y="6793210"/>
-            <a:ext cx="3466465" cy="571500"/>
+            <a:off x="572145" y="7205960"/>
+            <a:ext cx="2954909" cy="571500"/>
           </a:xfrm>
           <a:prstGeom prst="rect">
             <a:avLst/>
@@ -3783,7 +3845,7 @@
                 <a:ea typeface="Noto Serif Display Light" pitchFamily="34" charset="-122"/>
                 <a:cs typeface="Noto Serif Display Light" pitchFamily="34" charset="-120"/>
               </a:rPr>
-              <a:t>пять месяцев от пробника</a:t>
+              <a:t>один из самых ярких</a:t>
             </a:r>
             <a:endParaRPr lang="en-US" sz="2000" dirty="0"/>
           </a:p>
@@ -3803,7 +3865,7 @@
                 <a:ea typeface="Noto Serif Display Light" pitchFamily="34" charset="-122"/>
                 <a:cs typeface="Noto Serif Display Light" pitchFamily="34" charset="-120"/>
               </a:rPr>
-              <a:t>до официальных 1580</a:t>
+              <a:t>моментов моего лета</a:t>
             </a:r>
             <a:endParaRPr lang="en-US" sz="2000" dirty="0"/>
           </a:p>
@@ -3856,8 +3918,8 @@
         </p:nvSpPr>
         <p:spPr>
           <a:xfrm>
-            <a:off x="455960" y="406400"/>
-            <a:ext cx="1587500" cy="323850"/>
+            <a:off x="458490" y="406400"/>
+            <a:ext cx="2616200" cy="323850"/>
           </a:xfrm>
           <a:prstGeom prst="roundRect">
             <a:avLst>
@@ -3907,8 +3969,8 @@
         </p:nvSpPr>
         <p:spPr>
           <a:xfrm>
-            <a:off x="786160" y="482600"/>
-            <a:ext cx="1198118" cy="171450"/>
+            <a:off x="788690" y="482600"/>
+            <a:ext cx="2288540" cy="171450"/>
           </a:xfrm>
           <a:prstGeom prst="rect">
             <a:avLst/>
@@ -3935,7 +3997,7 @@
                 <a:ea typeface="IBM Plex Mono" pitchFamily="34" charset="-122"/>
                 <a:cs typeface="IBM Plex Mono" pitchFamily="34" charset="-120"/>
               </a:rPr>
-              <a:t>ОТЗЫВ · ЮСУФ</a:t>
+              <a:t>2025–2026 · ПОСТУПЛЕНИЕ</a:t>
             </a:r>
             <a:endParaRPr lang="en-US" sz="1000" dirty="0"/>
           </a:p>
@@ -3977,7 +4039,992 @@
                 <a:ea typeface="IBM Plex Mono" pitchFamily="34" charset="-122"/>
                 <a:cs typeface="IBM Plex Mono" pitchFamily="34" charset="-120"/>
               </a:rPr>
-              <a:t>04 / 04</a:t>
+              <a:t>04 / 05</a:t>
+            </a:r>
+            <a:endParaRPr lang="en-US" sz="1000" dirty="0"/>
+          </a:p>
+        </p:txBody>
+      </p:sp>
+      <p:sp>
+        <p:nvSpPr>
+          <p:cNvPr id="6" name="text-5"/>
+          <p:cNvSpPr txBox="1"/>
+          <p:nvPr/>
+        </p:nvSpPr>
+        <p:spPr>
+          <a:xfrm>
+            <a:off x="457200" y="952500"/>
+            <a:ext cx="6300216" cy="673100"/>
+          </a:xfrm>
+          <a:prstGeom prst="rect">
+            <a:avLst/>
+          </a:prstGeom>
+          <a:noFill/>
+          <a:ln/>
+        </p:spPr>
+        <p:txBody>
+          <a:bodyPr wrap="square" lIns="0" tIns="0" rIns="0" bIns="0" rtlCol="0" anchor="t"/>
+          <a:lstStyle/>
+          <a:p>
+            <a:pPr algn="l" indent="0" marL="0">
+              <a:lnSpc>
+                <a:spcPts val="4600"/>
+              </a:lnSpc>
+              <a:buNone/>
+            </a:pPr>
+            <a:r>
+              <a:rPr lang="en-US" sz="4600" b="1" spc="-160" kern="0" dirty="0">
+                <a:solidFill>
+                  <a:srgbClr val="0A0A0A"/>
+                </a:solidFill>
+                <a:latin typeface="Geist" pitchFamily="34" charset="0"/>
+                <a:ea typeface="Geist" pitchFamily="34" charset="-122"/>
+                <a:cs typeface="Geist" pitchFamily="34" charset="-120"/>
+              </a:rPr>
+              <a:t>Больше, чем </a:t>
+            </a:r>
+            <a:pPr algn="l" indent="0" marL="0">
+              <a:lnSpc>
+                <a:spcPts val="4600"/>
+              </a:lnSpc>
+              <a:buNone/>
+            </a:pPr>
+            <a:r>
+              <a:rPr lang="en-US" sz="5200" i="1" spc="-100" kern="0" dirty="0">
+                <a:solidFill>
+                  <a:srgbClr val="0A0A0A"/>
+                </a:solidFill>
+                <a:latin typeface="Noto Serif Display Light" pitchFamily="34" charset="0"/>
+                <a:ea typeface="Noto Serif Display Light" pitchFamily="34" charset="-122"/>
+                <a:cs typeface="Noto Serif Display Light" pitchFamily="34" charset="-120"/>
+              </a:rPr>
+              <a:t>SAT</a:t>
+            </a:r>
+            <a:endParaRPr lang="en-US" sz="4600" dirty="0"/>
+          </a:p>
+        </p:txBody>
+      </p:sp>
+      <p:sp>
+        <p:nvSpPr>
+          <p:cNvPr id="7" name="text-6"/>
+          <p:cNvSpPr txBox="1"/>
+          <p:nvPr/>
+        </p:nvSpPr>
+        <p:spPr>
+          <a:xfrm>
+            <a:off x="457200" y="1815405"/>
+            <a:ext cx="6300216" cy="908050"/>
+          </a:xfrm>
+          <a:prstGeom prst="rect">
+            <a:avLst/>
+          </a:prstGeom>
+          <a:noFill/>
+          <a:ln/>
+        </p:spPr>
+        <p:txBody>
+          <a:bodyPr wrap="square" lIns="0" tIns="0" rIns="0" bIns="0" rtlCol="0" anchor="t"/>
+          <a:lstStyle/>
+          <a:p>
+            <a:pPr algn="l" indent="0" marL="0">
+              <a:lnSpc>
+                <a:spcPts val="2380"/>
+              </a:lnSpc>
+              <a:buNone/>
+            </a:pPr>
+            <a:r>
+              <a:rPr lang="en-US" sz="1700" dirty="0">
+                <a:solidFill>
+                  <a:srgbClr val="2B2A27"/>
+                </a:solidFill>
+                <a:latin typeface="Geist" pitchFamily="34" charset="0"/>
+                <a:ea typeface="Geist" pitchFamily="34" charset="-122"/>
+                <a:cs typeface="Geist" pitchFamily="34" charset="-120"/>
+              </a:rPr>
+              <a:t>С прошлого года я сопровождаю Юсуфа в поступлении. Мы вместе работаем над эссе и над академической частью заявки.</a:t>
+            </a:r>
+            <a:endParaRPr lang="en-US" sz="1700" dirty="0"/>
+          </a:p>
+        </p:txBody>
+      </p:sp>
+      <p:sp>
+        <p:nvSpPr>
+          <p:cNvPr id="8" name="text-7"/>
+          <p:cNvSpPr txBox="1"/>
+          <p:nvPr/>
+        </p:nvSpPr>
+        <p:spPr>
+          <a:xfrm>
+            <a:off x="457200" y="2836366"/>
+            <a:ext cx="6300216" cy="908050"/>
+          </a:xfrm>
+          <a:prstGeom prst="rect">
+            <a:avLst/>
+          </a:prstGeom>
+          <a:noFill/>
+          <a:ln/>
+        </p:spPr>
+        <p:txBody>
+          <a:bodyPr wrap="square" lIns="0" tIns="0" rIns="0" bIns="0" rtlCol="0" anchor="t"/>
+          <a:lstStyle/>
+          <a:p>
+            <a:pPr algn="l" indent="0" marL="0">
+              <a:lnSpc>
+                <a:spcPts val="2380"/>
+              </a:lnSpc>
+              <a:buNone/>
+            </a:pPr>
+            <a:r>
+              <a:rPr lang="en-US" sz="1700" dirty="0">
+                <a:solidFill>
+                  <a:srgbClr val="2B2A27"/>
+                </a:solidFill>
+                <a:latin typeface="Geist" pitchFamily="34" charset="0"/>
+                <a:ea typeface="Geist" pitchFamily="34" charset="-122"/>
+                <a:cs typeface="Geist" pitchFamily="34" charset="-120"/>
+              </a:rPr>
+              <a:t>SAT был одной из частей. С марта по май мы занимались в основном Verbal, немного Math. Ещё больше он работал сам. 1580 это его труд.</a:t>
+            </a:r>
+            <a:endParaRPr lang="en-US" sz="1700" dirty="0"/>
+          </a:p>
+        </p:txBody>
+      </p:sp>
+      <p:sp>
+        <p:nvSpPr>
+          <p:cNvPr id="9" name="shape-8"/>
+          <p:cNvSpPr/>
+          <p:nvPr/>
+        </p:nvSpPr>
+        <p:spPr>
+          <a:xfrm rot="-120000">
+            <a:off x="457051" y="5715000"/>
+            <a:ext cx="2362200" cy="393700"/>
+          </a:xfrm>
+          <a:prstGeom prst="roundRect">
+            <a:avLst>
+              <a:gd name="adj" fmla="val 50000"/>
+            </a:avLst>
+          </a:prstGeom>
+          <a:solidFill>
+            <a:srgbClr val="FAF8F3"/>
+          </a:solidFill>
+          <a:ln w="12700">
+            <a:solidFill>
+              <a:srgbClr val="0A0A0A"/>
+            </a:solidFill>
+            <a:prstDash val="solid"/>
+          </a:ln>
+          <a:effectLst>
+            <a:outerShdw sx="100000" sy="100000" kx="0" ky="0" algn="bl" rotWithShape="0" blurRad="177800" dist="76200" dir="5400000">
+              <a:srgbClr val="000000">
+                <a:alpha val="22000"/>
+              </a:srgbClr>
+            </a:outerShdw>
+          </a:effectLst>
+        </p:spPr>
+      </p:sp>
+      <p:pic>
+        <p:nvPicPr>
+          <p:cNvPr id="10" name="svg-9" descr="preencoded.png">    </p:cNvPr>
+          <p:cNvPicPr>
+            <a:picLocks noChangeAspect="1"/>
+          </p:cNvPicPr>
+          <p:nvPr/>
+        </p:nvPicPr>
+        <p:blipFill>
+          <a:blip r:embed="rId3"/>
+          <a:stretch>
+            <a:fillRect/>
+          </a:stretch>
+        </p:blipFill>
+        <p:spPr>
+          <a:xfrm rot="-120000">
+            <a:off x="597484" y="5862758"/>
+            <a:ext cx="165100" cy="165100"/>
+          </a:xfrm>
+          <a:prstGeom prst="rect">
+            <a:avLst/>
+          </a:prstGeom>
+        </p:spPr>
+      </p:pic>
+      <p:sp>
+        <p:nvSpPr>
+          <p:cNvPr id="11" name="text-10"/>
+          <p:cNvSpPr txBox="1"/>
+          <p:nvPr/>
+        </p:nvSpPr>
+        <p:spPr>
+          <a:xfrm rot="-120000">
+            <a:off x="837978" y="5799689"/>
+            <a:ext cx="1951990" cy="215900"/>
+          </a:xfrm>
+          <a:prstGeom prst="rect">
+            <a:avLst/>
+          </a:prstGeom>
+          <a:noFill/>
+          <a:ln/>
+        </p:spPr>
+        <p:txBody>
+          <a:bodyPr wrap="square" lIns="0" tIns="0" rIns="0" bIns="0" rtlCol="0" anchor="t"/>
+          <a:lstStyle/>
+          <a:p>
+            <a:pPr algn="l" indent="0" marL="0">
+              <a:lnSpc>
+                <a:spcPts val="1560"/>
+              </a:lnSpc>
+              <a:buNone/>
+            </a:pPr>
+            <a:r>
+              <a:rPr lang="en-US" sz="1300" b="1" spc="-10" kern="0" dirty="0">
+                <a:solidFill>
+                  <a:srgbClr val="0A0A0A"/>
+                </a:solidFill>
+                <a:latin typeface="Geist" pitchFamily="34" charset="0"/>
+                <a:ea typeface="Geist" pitchFamily="34" charset="-122"/>
+                <a:cs typeface="Geist" pitchFamily="34" charset="-120"/>
+              </a:rPr>
+              <a:t>январь · пробник 1300</a:t>
+            </a:r>
+            <a:endParaRPr lang="en-US" sz="1300" dirty="0"/>
+          </a:p>
+        </p:txBody>
+      </p:sp>
+      <p:sp>
+        <p:nvSpPr>
+          <p:cNvPr id="12" name="shape-11"/>
+          <p:cNvSpPr/>
+          <p:nvPr/>
+        </p:nvSpPr>
+        <p:spPr>
+          <a:xfrm rot="120000">
+            <a:off x="1217811" y="6223000"/>
+            <a:ext cx="2279650" cy="393700"/>
+          </a:xfrm>
+          <a:prstGeom prst="roundRect">
+            <a:avLst>
+              <a:gd name="adj" fmla="val 50000"/>
+            </a:avLst>
+          </a:prstGeom>
+          <a:solidFill>
+            <a:srgbClr val="FAF8F3"/>
+          </a:solidFill>
+          <a:ln w="12700">
+            <a:solidFill>
+              <a:srgbClr val="0A0A0A"/>
+            </a:solidFill>
+            <a:prstDash val="solid"/>
+          </a:ln>
+          <a:effectLst>
+            <a:outerShdw sx="100000" sy="100000" kx="0" ky="0" algn="bl" rotWithShape="0" blurRad="177800" dist="76200" dir="5400000">
+              <a:srgbClr val="000000">
+                <a:alpha val="22000"/>
+              </a:srgbClr>
+            </a:outerShdw>
+          </a:effectLst>
+        </p:spPr>
+      </p:sp>
+      <p:pic>
+        <p:nvPicPr>
+          <p:cNvPr id="13" name="svg-12" descr="preencoded.png">    </p:cNvPr>
+          <p:cNvPicPr>
+            <a:picLocks noChangeAspect="1"/>
+          </p:cNvPicPr>
+          <p:nvPr/>
+        </p:nvPicPr>
+        <p:blipFill>
+          <a:blip r:embed="rId4"/>
+          <a:stretch>
+            <a:fillRect/>
+          </a:stretch>
+        </p:blipFill>
+        <p:spPr>
+          <a:xfrm rot="120000">
+            <a:off x="1359458" y="6305325"/>
+            <a:ext cx="165100" cy="165100"/>
+          </a:xfrm>
+          <a:prstGeom prst="rect">
+            <a:avLst/>
+          </a:prstGeom>
+        </p:spPr>
+      </p:pic>
+      <p:sp>
+        <p:nvSpPr>
+          <p:cNvPr id="14" name="text-13"/>
+          <p:cNvSpPr txBox="1"/>
+          <p:nvPr/>
+        </p:nvSpPr>
+        <p:spPr>
+          <a:xfrm rot="120000">
+            <a:off x="1598737" y="6316111"/>
+            <a:ext cx="1864487" cy="215900"/>
+          </a:xfrm>
+          <a:prstGeom prst="rect">
+            <a:avLst/>
+          </a:prstGeom>
+          <a:noFill/>
+          <a:ln/>
+        </p:spPr>
+        <p:txBody>
+          <a:bodyPr wrap="square" lIns="0" tIns="0" rIns="0" bIns="0" rtlCol="0" anchor="t"/>
+          <a:lstStyle/>
+          <a:p>
+            <a:pPr algn="l" indent="0" marL="0">
+              <a:lnSpc>
+                <a:spcPts val="1560"/>
+              </a:lnSpc>
+              <a:buNone/>
+            </a:pPr>
+            <a:r>
+              <a:rPr lang="en-US" sz="1300" b="1" spc="-10" kern="0" dirty="0">
+                <a:solidFill>
+                  <a:srgbClr val="0A0A0A"/>
+                </a:solidFill>
+                <a:latin typeface="Geist" pitchFamily="34" charset="0"/>
+                <a:ea typeface="Geist" pitchFamily="34" charset="-122"/>
+                <a:cs typeface="Geist" pitchFamily="34" charset="-120"/>
+              </a:rPr>
+              <a:t>март–май · уроки SAT</a:t>
+            </a:r>
+            <a:endParaRPr lang="en-US" sz="1300" dirty="0"/>
+          </a:p>
+        </p:txBody>
+      </p:sp>
+      <p:sp>
+        <p:nvSpPr>
+          <p:cNvPr id="15" name="shape-14"/>
+          <p:cNvSpPr/>
+          <p:nvPr/>
+        </p:nvSpPr>
+        <p:spPr>
+          <a:xfrm rot="-120000">
+            <a:off x="1979811" y="6731000"/>
+            <a:ext cx="1803400" cy="393700"/>
+          </a:xfrm>
+          <a:prstGeom prst="roundRect">
+            <a:avLst>
+              <a:gd name="adj" fmla="val 50000"/>
+            </a:avLst>
+          </a:prstGeom>
+          <a:solidFill>
+            <a:srgbClr val="FAF8F3"/>
+          </a:solidFill>
+          <a:ln w="12700">
+            <a:solidFill>
+              <a:srgbClr val="0A0A0A"/>
+            </a:solidFill>
+            <a:prstDash val="solid"/>
+          </a:ln>
+          <a:effectLst>
+            <a:outerShdw sx="100000" sy="100000" kx="0" ky="0" algn="bl" rotWithShape="0" blurRad="177800" dist="76200" dir="5400000">
+              <a:srgbClr val="000000">
+                <a:alpha val="22000"/>
+              </a:srgbClr>
+            </a:outerShdw>
+          </a:effectLst>
+        </p:spPr>
+      </p:sp>
+      <p:pic>
+        <p:nvPicPr>
+          <p:cNvPr id="16" name="svg-15" descr="preencoded.png">    </p:cNvPr>
+          <p:cNvPicPr>
+            <a:picLocks noChangeAspect="1"/>
+          </p:cNvPicPr>
+          <p:nvPr/>
+        </p:nvPicPr>
+        <p:blipFill>
+          <a:blip r:embed="rId5"/>
+          <a:stretch>
+            <a:fillRect/>
+          </a:stretch>
+        </p:blipFill>
+        <p:spPr>
+          <a:xfrm rot="-120000">
+            <a:off x="2121313" y="6868964"/>
+            <a:ext cx="165100" cy="165100"/>
+          </a:xfrm>
+          <a:prstGeom prst="rect">
+            <a:avLst/>
+          </a:prstGeom>
+        </p:spPr>
+      </p:pic>
+      <p:sp>
+        <p:nvSpPr>
+          <p:cNvPr id="17" name="text-16"/>
+          <p:cNvSpPr txBox="1"/>
+          <p:nvPr/>
+        </p:nvSpPr>
+        <p:spPr>
+          <a:xfrm rot="-120000">
+            <a:off x="2360737" y="6815689"/>
+            <a:ext cx="1359662" cy="215900"/>
+          </a:xfrm>
+          <a:prstGeom prst="rect">
+            <a:avLst/>
+          </a:prstGeom>
+          <a:noFill/>
+          <a:ln/>
+        </p:spPr>
+        <p:txBody>
+          <a:bodyPr wrap="square" lIns="0" tIns="0" rIns="0" bIns="0" rtlCol="0" anchor="t"/>
+          <a:lstStyle/>
+          <a:p>
+            <a:pPr algn="l" indent="0" marL="0">
+              <a:lnSpc>
+                <a:spcPts val="1560"/>
+              </a:lnSpc>
+              <a:buNone/>
+            </a:pPr>
+            <a:r>
+              <a:rPr lang="en-US" sz="1300" b="1" spc="-10" kern="0" dirty="0">
+                <a:solidFill>
+                  <a:srgbClr val="0A0A0A"/>
+                </a:solidFill>
+                <a:latin typeface="Geist" pitchFamily="34" charset="0"/>
+                <a:ea typeface="Geist" pitchFamily="34" charset="-122"/>
+                <a:cs typeface="Geist" pitchFamily="34" charset="-120"/>
+              </a:rPr>
+              <a:t>июнь · SAT 1580</a:t>
+            </a:r>
+            <a:endParaRPr lang="en-US" sz="1300" dirty="0"/>
+          </a:p>
+        </p:txBody>
+      </p:sp>
+      <p:pic>
+        <p:nvPicPr>
+          <p:cNvPr id="18" name="svg-17" descr="preencoded.png">    </p:cNvPr>
+          <p:cNvPicPr>
+            <a:picLocks noChangeAspect="1"/>
+          </p:cNvPicPr>
+          <p:nvPr/>
+        </p:nvPicPr>
+        <p:blipFill>
+          <a:blip r:embed="rId6"/>
+          <a:stretch>
+            <a:fillRect/>
+          </a:stretch>
+        </p:blipFill>
+        <p:spPr>
+          <a:xfrm>
+            <a:off x="6007100" y="4064000"/>
+            <a:ext cx="279400" cy="279400"/>
+          </a:xfrm>
+          <a:prstGeom prst="rect">
+            <a:avLst/>
+          </a:prstGeom>
+        </p:spPr>
+      </p:pic>
+      <p:pic>
+        <p:nvPicPr>
+          <p:cNvPr id="19" name="svg-18" descr="preencoded.png">    </p:cNvPr>
+          <p:cNvPicPr>
+            <a:picLocks noChangeAspect="1"/>
+          </p:cNvPicPr>
+          <p:nvPr/>
+        </p:nvPicPr>
+        <p:blipFill>
+          <a:blip r:embed="rId7"/>
+          <a:stretch>
+            <a:fillRect/>
+          </a:stretch>
+        </p:blipFill>
+        <p:spPr>
+          <a:xfrm>
+            <a:off x="5461000" y="7302500"/>
+            <a:ext cx="190500" cy="190500"/>
+          </a:xfrm>
+          <a:prstGeom prst="rect">
+            <a:avLst/>
+          </a:prstGeom>
+        </p:spPr>
+      </p:pic>
+      <p:sp>
+        <p:nvSpPr>
+          <p:cNvPr id="20" name="text-19"/>
+          <p:cNvSpPr txBox="1"/>
+          <p:nvPr/>
+        </p:nvSpPr>
+        <p:spPr>
+          <a:xfrm>
+            <a:off x="457845" y="7969250"/>
+            <a:ext cx="895223" cy="171450"/>
+          </a:xfrm>
+          <a:prstGeom prst="rect">
+            <a:avLst/>
+          </a:prstGeom>
+          <a:noFill/>
+          <a:ln/>
+        </p:spPr>
+        <p:txBody>
+          <a:bodyPr wrap="square" lIns="0" tIns="0" rIns="0" bIns="0" rtlCol="0" anchor="t"/>
+          <a:lstStyle/>
+          <a:p>
+            <a:pPr algn="l" indent="0" marL="0">
+              <a:lnSpc>
+                <a:spcPts val="1200"/>
+              </a:lnSpc>
+              <a:buNone/>
+            </a:pPr>
+            <a:r>
+              <a:rPr lang="en-US" sz="1000" spc="140" kern="0" dirty="0">
+                <a:solidFill>
+                  <a:srgbClr val="0A0A0A"/>
+                </a:solidFill>
+                <a:latin typeface="IBM Plex Mono" pitchFamily="34" charset="0"/>
+                <a:ea typeface="IBM Plex Mono" pitchFamily="34" charset="-122"/>
+                <a:cs typeface="IBM Plex Mono" pitchFamily="34" charset="-120"/>
+              </a:rPr>
+              <a:t>@NURZYCOM</a:t>
+            </a:r>
+            <a:endParaRPr lang="en-US" sz="1000" dirty="0"/>
+          </a:p>
+        </p:txBody>
+      </p:sp>
+      <p:sp>
+        <p:nvSpPr>
+          <p:cNvPr id="21" name="shape-20"/>
+          <p:cNvSpPr/>
+          <p:nvPr/>
+        </p:nvSpPr>
+        <p:spPr>
+          <a:xfrm>
+            <a:off x="5340945" y="7893050"/>
+            <a:ext cx="1060450" cy="323850"/>
+          </a:xfrm>
+          <a:prstGeom prst="roundRect">
+            <a:avLst>
+              <a:gd name="adj" fmla="val 50000"/>
+            </a:avLst>
+          </a:prstGeom>
+          <a:solidFill>
+            <a:srgbClr val="0A0A0A"/>
+          </a:solidFill>
+          <a:ln/>
+        </p:spPr>
+      </p:sp>
+      <p:sp>
+        <p:nvSpPr>
+          <p:cNvPr id="22" name="text-21"/>
+          <p:cNvSpPr txBox="1"/>
+          <p:nvPr/>
+        </p:nvSpPr>
+        <p:spPr>
+          <a:xfrm>
+            <a:off x="5480645" y="7969250"/>
+            <a:ext cx="599059" cy="171450"/>
+          </a:xfrm>
+          <a:prstGeom prst="rect">
+            <a:avLst/>
+          </a:prstGeom>
+          <a:noFill/>
+          <a:ln/>
+        </p:spPr>
+        <p:txBody>
+          <a:bodyPr wrap="square" lIns="0" tIns="0" rIns="0" bIns="0" rtlCol="0" anchor="t"/>
+          <a:lstStyle/>
+          <a:p>
+            <a:pPr algn="l" indent="0" marL="0">
+              <a:lnSpc>
+                <a:spcPts val="1200"/>
+              </a:lnSpc>
+              <a:buNone/>
+            </a:pPr>
+            <a:r>
+              <a:rPr lang="en-US" sz="1000" spc="140" kern="0" dirty="0">
+                <a:solidFill>
+                  <a:srgbClr val="FAF8F3"/>
+                </a:solidFill>
+                <a:latin typeface="IBM Plex Mono" pitchFamily="34" charset="0"/>
+                <a:ea typeface="IBM Plex Mono" pitchFamily="34" charset="-122"/>
+                <a:cs typeface="IBM Plex Mono" pitchFamily="34" charset="-120"/>
+              </a:rPr>
+              <a:t>ЛИСТАЙ</a:t>
+            </a:r>
+            <a:endParaRPr lang="en-US" sz="1000" dirty="0"/>
+          </a:p>
+        </p:txBody>
+      </p:sp>
+      <p:pic>
+        <p:nvPicPr>
+          <p:cNvPr id="23" name="svg-22" descr="preencoded.png">    </p:cNvPr>
+          <p:cNvPicPr>
+            <a:picLocks noChangeAspect="1"/>
+          </p:cNvPicPr>
+          <p:nvPr/>
+        </p:nvPicPr>
+        <p:blipFill>
+          <a:blip r:embed="rId8"/>
+          <a:stretch>
+            <a:fillRect/>
+          </a:stretch>
+        </p:blipFill>
+        <p:spPr>
+          <a:xfrm>
+            <a:off x="6121400" y="7985125"/>
+            <a:ext cx="139700" cy="139700"/>
+          </a:xfrm>
+          <a:prstGeom prst="rect">
+            <a:avLst/>
+          </a:prstGeom>
+        </p:spPr>
+      </p:pic>
+      <p:sp>
+        <p:nvSpPr>
+          <p:cNvPr id="24" name="shape-23"/>
+          <p:cNvSpPr/>
+          <p:nvPr/>
+        </p:nvSpPr>
+        <p:spPr>
+          <a:xfrm rot="-180000">
+            <a:off x="455811" y="4635500"/>
+            <a:ext cx="1308100" cy="558800"/>
+          </a:xfrm>
+          <a:prstGeom prst="roundRect">
+            <a:avLst>
+              <a:gd name="adj" fmla="val 50000"/>
+            </a:avLst>
+          </a:prstGeom>
+          <a:solidFill>
+            <a:srgbClr val="0A0A0A"/>
+          </a:solidFill>
+          <a:ln/>
+          <a:effectLst>
+            <a:outerShdw sx="100000" sy="100000" kx="0" ky="0" algn="bl" rotWithShape="0" blurRad="177800" dist="76200" dir="5400000">
+              <a:srgbClr val="000000">
+                <a:alpha val="22000"/>
+              </a:srgbClr>
+            </a:outerShdw>
+          </a:effectLst>
+        </p:spPr>
+      </p:sp>
+      <p:pic>
+        <p:nvPicPr>
+          <p:cNvPr id="25" name="svg-24" descr="preencoded.png">    </p:cNvPr>
+          <p:cNvPicPr>
+            <a:picLocks noChangeAspect="1"/>
+          </p:cNvPicPr>
+          <p:nvPr/>
+        </p:nvPicPr>
+        <p:blipFill>
+          <a:blip r:embed="rId9"/>
+          <a:stretch>
+            <a:fillRect/>
+          </a:stretch>
+        </p:blipFill>
+        <p:spPr>
+          <a:xfrm rot="-180000">
+            <a:off x="648159" y="4805441"/>
+            <a:ext cx="254000" cy="254000"/>
+          </a:xfrm>
+          <a:prstGeom prst="rect">
+            <a:avLst/>
+          </a:prstGeom>
+        </p:spPr>
+      </p:pic>
+      <p:sp>
+        <p:nvSpPr>
+          <p:cNvPr id="26" name="text-25"/>
+          <p:cNvSpPr txBox="1"/>
+          <p:nvPr/>
+        </p:nvSpPr>
+        <p:spPr>
+          <a:xfrm rot="-180000">
+            <a:off x="976285" y="4741159"/>
+            <a:ext cx="632714" cy="330200"/>
+          </a:xfrm>
+          <a:prstGeom prst="rect">
+            <a:avLst/>
+          </a:prstGeom>
+          <a:noFill/>
+          <a:ln/>
+        </p:spPr>
+        <p:txBody>
+          <a:bodyPr wrap="square" lIns="0" tIns="0" rIns="0" bIns="0" rtlCol="0" anchor="t"/>
+          <a:lstStyle/>
+          <a:p>
+            <a:pPr algn="l" indent="0" marL="0">
+              <a:lnSpc>
+                <a:spcPts val="2400"/>
+              </a:lnSpc>
+              <a:buNone/>
+            </a:pPr>
+            <a:r>
+              <a:rPr lang="en-US" sz="2000" b="1" spc="-20" kern="0" dirty="0">
+                <a:solidFill>
+                  <a:srgbClr val="FAF8F3"/>
+                </a:solidFill>
+                <a:latin typeface="Geist" pitchFamily="34" charset="0"/>
+                <a:ea typeface="Geist" pitchFamily="34" charset="-122"/>
+                <a:cs typeface="Geist" pitchFamily="34" charset="-120"/>
+              </a:rPr>
+              <a:t>эссе</a:t>
+            </a:r>
+            <a:endParaRPr lang="en-US" sz="2000" dirty="0"/>
+          </a:p>
+        </p:txBody>
+      </p:sp>
+      <p:sp>
+        <p:nvSpPr>
+          <p:cNvPr id="27" name="shape-26"/>
+          <p:cNvSpPr/>
+          <p:nvPr/>
+        </p:nvSpPr>
+        <p:spPr>
+          <a:xfrm rot="180000">
+            <a:off x="2666256" y="4699000"/>
+            <a:ext cx="3492500" cy="558800"/>
+          </a:xfrm>
+          <a:prstGeom prst="roundRect">
+            <a:avLst>
+              <a:gd name="adj" fmla="val 50000"/>
+            </a:avLst>
+          </a:prstGeom>
+          <a:solidFill>
+            <a:srgbClr val="0A0A0A"/>
+          </a:solidFill>
+          <a:ln/>
+          <a:effectLst>
+            <a:outerShdw sx="100000" sy="100000" kx="0" ky="0" algn="bl" rotWithShape="0" blurRad="177800" dist="76200" dir="5400000">
+              <a:srgbClr val="000000">
+                <a:alpha val="22000"/>
+              </a:srgbClr>
+            </a:outerShdw>
+          </a:effectLst>
+        </p:spPr>
+      </p:sp>
+      <p:pic>
+        <p:nvPicPr>
+          <p:cNvPr id="28" name="svg-27" descr="preencoded.png">    </p:cNvPr>
+          <p:cNvPicPr>
+            <a:picLocks noChangeAspect="1"/>
+          </p:cNvPicPr>
+          <p:nvPr/>
+        </p:nvPicPr>
+        <p:blipFill>
+          <a:blip r:embed="rId10"/>
+          <a:stretch>
+            <a:fillRect/>
+          </a:stretch>
+        </p:blipFill>
+        <p:spPr>
+          <a:xfrm rot="180000">
+            <a:off x="2859457" y="4776664"/>
+            <a:ext cx="254000" cy="254000"/>
+          </a:xfrm>
+          <a:prstGeom prst="rect">
+            <a:avLst/>
+          </a:prstGeom>
+        </p:spPr>
+      </p:pic>
+      <p:sp>
+        <p:nvSpPr>
+          <p:cNvPr id="29" name="text-28"/>
+          <p:cNvSpPr txBox="1"/>
+          <p:nvPr/>
+        </p:nvSpPr>
+        <p:spPr>
+          <a:xfrm rot="180000">
+            <a:off x="3186730" y="4821941"/>
+            <a:ext cx="2948178" cy="330200"/>
+          </a:xfrm>
+          <a:prstGeom prst="rect">
+            <a:avLst/>
+          </a:prstGeom>
+          <a:noFill/>
+          <a:ln/>
+        </p:spPr>
+        <p:txBody>
+          <a:bodyPr wrap="square" lIns="0" tIns="0" rIns="0" bIns="0" rtlCol="0" anchor="t"/>
+          <a:lstStyle/>
+          <a:p>
+            <a:pPr algn="l" indent="0" marL="0">
+              <a:lnSpc>
+                <a:spcPts val="2400"/>
+              </a:lnSpc>
+              <a:buNone/>
+            </a:pPr>
+            <a:r>
+              <a:rPr lang="en-US" sz="2000" b="1" spc="-20" kern="0" dirty="0">
+                <a:solidFill>
+                  <a:srgbClr val="FAF8F3"/>
+                </a:solidFill>
+                <a:latin typeface="Geist" pitchFamily="34" charset="0"/>
+                <a:ea typeface="Geist" pitchFamily="34" charset="-122"/>
+                <a:cs typeface="Geist" pitchFamily="34" charset="-120"/>
+              </a:rPr>
+              <a:t>академическая часть</a:t>
+            </a:r>
+            <a:endParaRPr lang="en-US" sz="2000" dirty="0"/>
+          </a:p>
+        </p:txBody>
+      </p:sp>
+    </p:spTree>
+  </p:cSld>
+  <p:clrMapOvr>
+    <a:masterClrMapping/>
+  </p:clrMapOvr>
+</p:sld>
+</file>
+
+<file path=ppt/slides/slide5.xml><?xml version="1.0" encoding="utf-8"?>
+<p:sld xmlns:a="http://schemas.openxmlformats.org/drawingml/2006/main" xmlns:r="http://schemas.openxmlformats.org/officeDocument/2006/relationships" xmlns:p="http://schemas.openxmlformats.org/presentationml/2006/main">
+  <p:cSld name="Slide 5">
+    <p:bg>
+      <p:bgPr>
+        <a:blipFill dpi="0" rotWithShape="1">
+          <a:blip r:embed="rId1">
+            <a:lum/>
+          </a:blip>
+          <a:srcRect/>
+          <a:stretch>
+            <a:fillRect/>
+          </a:stretch>
+        </a:blipFill>
+        <a:effectLst/>
+      </p:bgPr>
+    </p:bg>
+    <p:spTree>
+      <p:nvGrpSpPr>
+        <p:cNvPr id="1" name=""/>
+        <p:cNvGrpSpPr/>
+        <p:nvPr/>
+      </p:nvGrpSpPr>
+      <p:grpSpPr>
+        <a:xfrm>
+          <a:off x="0" y="0"/>
+          <a:ext cx="0" cy="0"/>
+          <a:chOff x="0" y="0"/>
+          <a:chExt cx="0" cy="0"/>
+        </a:xfrm>
+      </p:grpSpPr>
+      <p:sp>
+        <p:nvSpPr>
+          <p:cNvPr id="2" name="shape-1"/>
+          <p:cNvSpPr/>
+          <p:nvPr/>
+        </p:nvSpPr>
+        <p:spPr>
+          <a:xfrm>
+            <a:off x="455960" y="406400"/>
+            <a:ext cx="1587500" cy="323850"/>
+          </a:xfrm>
+          <a:prstGeom prst="roundRect">
+            <a:avLst>
+              <a:gd name="adj" fmla="val 50000"/>
+            </a:avLst>
+          </a:prstGeom>
+          <a:solidFill>
+            <a:srgbClr val="FAF8F3"/>
+          </a:solidFill>
+          <a:ln w="12700">
+            <a:solidFill>
+              <a:srgbClr val="0A0A0A"/>
+            </a:solidFill>
+            <a:prstDash val="solid"/>
+          </a:ln>
+        </p:spPr>
+      </p:sp>
+      <p:pic>
+        <p:nvPicPr>
+          <p:cNvPr id="3" name="svg-2" descr="preencoded.png">    </p:cNvPr>
+          <p:cNvPicPr>
+            <a:picLocks noChangeAspect="1"/>
+          </p:cNvPicPr>
+          <p:nvPr/>
+        </p:nvPicPr>
+        <p:blipFill>
+          <a:blip r:embed="rId2"/>
+          <a:stretch>
+            <a:fillRect/>
+          </a:stretch>
+        </p:blipFill>
+        <p:spPr>
+          <a:xfrm>
+            <a:off x="584200" y="498475"/>
+            <a:ext cx="139700" cy="139700"/>
+          </a:xfrm>
+          <a:prstGeom prst="rect">
+            <a:avLst/>
+          </a:prstGeom>
+        </p:spPr>
+      </p:pic>
+      <p:sp>
+        <p:nvSpPr>
+          <p:cNvPr id="4" name="text-3"/>
+          <p:cNvSpPr txBox="1"/>
+          <p:nvPr/>
+        </p:nvSpPr>
+        <p:spPr>
+          <a:xfrm>
+            <a:off x="786160" y="482600"/>
+            <a:ext cx="1198118" cy="171450"/>
+          </a:xfrm>
+          <a:prstGeom prst="rect">
+            <a:avLst/>
+          </a:prstGeom>
+          <a:noFill/>
+          <a:ln/>
+        </p:spPr>
+        <p:txBody>
+          <a:bodyPr wrap="square" lIns="0" tIns="0" rIns="0" bIns="0" rtlCol="0" anchor="t"/>
+          <a:lstStyle/>
+          <a:p>
+            <a:pPr algn="l" indent="0" marL="0">
+              <a:lnSpc>
+                <a:spcPts val="1200"/>
+              </a:lnSpc>
+              <a:buNone/>
+            </a:pPr>
+            <a:r>
+              <a:rPr lang="en-US" sz="1000" spc="140" kern="0" dirty="0">
+                <a:solidFill>
+                  <a:srgbClr val="0A0A0A"/>
+                </a:solidFill>
+                <a:latin typeface="IBM Plex Mono" pitchFamily="34" charset="0"/>
+                <a:ea typeface="IBM Plex Mono" pitchFamily="34" charset="-122"/>
+                <a:cs typeface="IBM Plex Mono" pitchFamily="34" charset="-120"/>
+              </a:rPr>
+              <a:t>ОТЗЫВ · ЮСУФ</a:t>
+            </a:r>
+            <a:endParaRPr lang="en-US" sz="1000" dirty="0"/>
+          </a:p>
+        </p:txBody>
+      </p:sp>
+      <p:sp>
+        <p:nvSpPr>
+          <p:cNvPr id="5" name="text-4"/>
+          <p:cNvSpPr txBox="1"/>
+          <p:nvPr/>
+        </p:nvSpPr>
+        <p:spPr>
+          <a:xfrm>
+            <a:off x="5741640" y="482600"/>
+            <a:ext cx="700024" cy="171450"/>
+          </a:xfrm>
+          <a:prstGeom prst="rect">
+            <a:avLst/>
+          </a:prstGeom>
+          <a:noFill/>
+          <a:ln/>
+        </p:spPr>
+        <p:txBody>
+          <a:bodyPr wrap="square" lIns="0" tIns="0" rIns="0" bIns="0" rtlCol="0" anchor="t"/>
+          <a:lstStyle/>
+          <a:p>
+            <a:pPr algn="l" indent="0" marL="0">
+              <a:lnSpc>
+                <a:spcPts val="1200"/>
+              </a:lnSpc>
+              <a:buNone/>
+            </a:pPr>
+            <a:r>
+              <a:rPr lang="en-US" sz="1000" spc="140" kern="0" dirty="0">
+                <a:solidFill>
+                  <a:srgbClr val="0A0A0A"/>
+                </a:solidFill>
+                <a:latin typeface="IBM Plex Mono" pitchFamily="34" charset="0"/>
+                <a:ea typeface="IBM Plex Mono" pitchFamily="34" charset="-122"/>
+                <a:cs typeface="IBM Plex Mono" pitchFamily="34" charset="-120"/>
+              </a:rPr>
+              <a:t>05 / 05</a:t>
             </a:r>
             <a:endParaRPr lang="en-US" sz="1000" dirty="0"/>
           </a:p>

</xml_diff>

<commit_message>
Yussuf carousel: zoomed cover, blurred report details, OnAiTynys trip, centred quote
Co-Authored-By: Claude Opus 5.5 <noreply@anthropic.com>
Claude-Session: https://claude.ai/code/session_01EUKBNPzc7y2DXSfnei23HU
</commit_message>
<xml_diff>
--- a/social/pptx/yussuf-1580.pptx
+++ b/social/pptx/yussuf-1580.pptx
@@ -3345,8 +3345,8 @@
         </p:nvSpPr>
         <p:spPr>
           <a:xfrm>
-            <a:off x="457002" y="1752600"/>
-            <a:ext cx="6158865" cy="533400"/>
+            <a:off x="457200" y="1751905"/>
+            <a:ext cx="6300216" cy="774700"/>
           </a:xfrm>
           <a:prstGeom prst="rect">
             <a:avLst/>
@@ -3360,12 +3360,12 @@
           <a:p>
             <a:pPr algn="l" indent="0" marL="0">
               <a:lnSpc>
-                <a:spcPts val="2100"/>
-              </a:lnSpc>
-              <a:buNone/>
-            </a:pPr>
-            <a:r>
-              <a:rPr lang="en-US" sz="1500" dirty="0">
+                <a:spcPts val="2030"/>
+              </a:lnSpc>
+              <a:buNone/>
+            </a:pPr>
+            <a:r>
+              <a:rPr lang="en-US" sz="1450" dirty="0">
                 <a:solidFill>
                   <a:srgbClr val="2B2A27"/>
                 </a:solidFill>
@@ -3373,9 +3373,9 @@
                 <a:ea typeface="Geist" pitchFamily="34" charset="-122"/>
                 <a:cs typeface="Geist" pitchFamily="34" charset="-120"/>
               </a:rPr>
-              <a:t>Летом Юсуф поехал на международный конкурс во Францию. Там мы вместе и открыли его результат.</a:t>
-            </a:r>
-            <a:endParaRPr lang="en-US" sz="1500" dirty="0"/>
+              <a:t>Летом Юсуф поехал в Европу на международный стартап‑конкурс со своим проектом OnAiTynys, поездку профинансировали. Во Франции мы вместе открыли его результат.</a:t>
+            </a:r>
+            <a:endParaRPr lang="en-US" sz="1450" dirty="0"/>
           </a:p>
         </p:txBody>
       </p:sp>
@@ -3387,8 +3387,8 @@
         </p:nvSpPr>
         <p:spPr>
           <a:xfrm rot="120000">
-            <a:off x="698500" y="2984500"/>
-            <a:ext cx="5207000" cy="4076700"/>
+            <a:off x="952500" y="3175000"/>
+            <a:ext cx="4699000" cy="3695700"/>
           </a:xfrm>
           <a:prstGeom prst="rect">
             <a:avLst/>
@@ -3414,7 +3414,7 @@
         </p:nvSpPr>
         <p:spPr>
           <a:xfrm rot="-1680000">
-            <a:off x="516201" y="2788322"/>
+            <a:off x="763399" y="2987570"/>
             <a:ext cx="952500" cy="279400"/>
           </a:xfrm>
           <a:prstGeom prst="rect">
@@ -3436,7 +3436,7 @@
         </p:nvSpPr>
         <p:spPr>
           <a:xfrm rot="1680000">
-            <a:off x="5300742" y="2968109"/>
+            <a:off x="5040248" y="3149629"/>
             <a:ext cx="952500" cy="279400"/>
           </a:xfrm>
           <a:prstGeom prst="rect">
@@ -3458,8 +3458,8 @@
         </p:nvSpPr>
         <p:spPr>
           <a:xfrm rot="120000">
-            <a:off x="817897" y="3098889"/>
-            <a:ext cx="4978400" cy="3556000"/>
+            <a:off x="1071897" y="3289389"/>
+            <a:ext cx="4470400" cy="3175000"/>
           </a:xfrm>
           <a:prstGeom prst="rect">
             <a:avLst/>
@@ -3486,8 +3486,8 @@
         </p:blipFill>
         <p:spPr>
           <a:xfrm rot="120000">
-            <a:off x="817897" y="3098889"/>
-            <a:ext cx="4978400" cy="3556000"/>
+            <a:off x="1071897" y="3289389"/>
+            <a:ext cx="4470400" cy="3175000"/>
           </a:xfrm>
           <a:prstGeom prst="rect">
             <a:avLst/>
@@ -3502,8 +3502,8 @@
         </p:nvSpPr>
         <p:spPr>
           <a:xfrm rot="120000">
-            <a:off x="531422" y="6679102"/>
-            <a:ext cx="5415280" cy="292100"/>
+            <a:off x="802231" y="6488717"/>
+            <a:ext cx="4886960" cy="292100"/>
           </a:xfrm>
           <a:prstGeom prst="rect">
             <a:avLst/>
@@ -3552,7 +3552,7 @@
         </p:blipFill>
         <p:spPr>
           <a:xfrm>
-            <a:off x="5207000" y="7112000"/>
+            <a:off x="5715000" y="7175500"/>
             <a:ext cx="279400" cy="279400"/>
           </a:xfrm>
           <a:prstGeom prst="rect">
@@ -3576,7 +3576,7 @@
         </p:blipFill>
         <p:spPr>
           <a:xfrm>
-            <a:off x="444500" y="2730500"/>
+            <a:off x="444500" y="2984500"/>
             <a:ext cx="190500" cy="190500"/>
           </a:xfrm>
           <a:prstGeom prst="rect">
@@ -3722,7 +3722,7 @@
         </p:nvSpPr>
         <p:spPr>
           <a:xfrm rot="-360000">
-            <a:off x="5036741" y="2794000"/>
+            <a:off x="5036741" y="2984500"/>
             <a:ext cx="1441450" cy="425450"/>
           </a:xfrm>
           <a:prstGeom prst="roundRect">
@@ -3759,7 +3759,7 @@
         </p:blipFill>
         <p:spPr>
           <a:xfrm rot="-360000">
-            <a:off x="5192881" y="2953787"/>
+            <a:off x="5192881" y="3144287"/>
             <a:ext cx="203200" cy="203200"/>
           </a:xfrm>
           <a:prstGeom prst="rect">
@@ -3775,7 +3775,7 @@
         </p:nvSpPr>
         <p:spPr>
           <a:xfrm rot="-360000">
-            <a:off x="5467775" y="2868297"/>
+            <a:off x="5467775" y="3058797"/>
             <a:ext cx="908685" cy="247650"/>
           </a:xfrm>
           <a:prstGeom prst="rect">
@@ -3817,7 +3817,7 @@
         </p:nvSpPr>
         <p:spPr>
           <a:xfrm rot="-180000">
-            <a:off x="572145" y="7205960"/>
+            <a:off x="508645" y="7047210"/>
             <a:ext cx="2954909" cy="571500"/>
           </a:xfrm>
           <a:prstGeom prst="rect">
@@ -5097,7 +5097,7 @@
         </p:nvSpPr>
         <p:spPr>
           <a:xfrm rot="-72000">
-            <a:off x="457200" y="2094706"/>
+            <a:off x="457200" y="2520950"/>
             <a:ext cx="5943600" cy="3530600"/>
           </a:xfrm>
           <a:prstGeom prst="rect">
@@ -5124,7 +5124,7 @@
         </p:nvSpPr>
         <p:spPr>
           <a:xfrm rot="-252000">
-            <a:off x="2916329" y="1981581"/>
+            <a:off x="2916329" y="2407825"/>
             <a:ext cx="952500" cy="279400"/>
           </a:xfrm>
           <a:prstGeom prst="rect">
@@ -5146,7 +5146,7 @@
         </p:nvSpPr>
         <p:spPr>
           <a:xfrm rot="-72000">
-            <a:off x="835208" y="2501138"/>
+            <a:off x="835208" y="2927381"/>
             <a:ext cx="5492496" cy="2432050"/>
           </a:xfrm>
           <a:prstGeom prst="rect">
@@ -5174,7 +5174,7 @@
                 <a:ea typeface="Geist" pitchFamily="34" charset="-122"/>
                 <a:cs typeface="Geist" pitchFamily="34" charset="-120"/>
               </a:rPr>
-              <a:t>«Я честно говорю, тьютора лучше Нурасыла вряд ли можно найти. В потоке бесконечных компаний, реклам и т.д. Нурасыл — это личность, а не просто лого. Он умнейший человек, которого я встречал, и он буквально излучает теплоту и поддержку, ведь сам он очень добрый! Я многому научился у него, и благодарен, что именно он сопровождает меня на моем пути.»</a:t>
+              <a:t>«Я честно говорю, тьютора лучше Нурасыла вряд ли можно найти. В потоке бесконечных компаний, реклам и т.д. Нурасыл — это личность, а не просто лого. Он один из самых умных людей, которых я встречал, и он буквально излучает теплоту и поддержку, ведь сам он очень добрый! Я многому научился у него, и благодарен, что именно он сопровождает меня на моем пути.»</a:t>
             </a:r>
             <a:endParaRPr lang="en-US" sz="1650" dirty="0"/>
           </a:p>
@@ -5188,7 +5188,7 @@
         </p:nvSpPr>
         <p:spPr>
           <a:xfrm rot="-72000">
-            <a:off x="866443" y="5122567"/>
+            <a:off x="866443" y="5548811"/>
             <a:ext cx="5492496" cy="171450"/>
           </a:xfrm>
           <a:prstGeom prst="rect">
@@ -5309,101 +5309,6 @@
               <a:t>@NURZYCOM</a:t>
             </a:r>
             <a:endParaRPr lang="en-US" sz="1000" dirty="0"/>
-          </a:p>
-        </p:txBody>
-      </p:sp>
-      <p:sp>
-        <p:nvSpPr>
-          <p:cNvPr id="14" name="shape-13"/>
-          <p:cNvSpPr/>
-          <p:nvPr/>
-        </p:nvSpPr>
-        <p:spPr>
-          <a:xfrm rot="300000">
-            <a:off x="4552156" y="6731000"/>
-            <a:ext cx="1797050" cy="425450"/>
-          </a:xfrm>
-          <a:prstGeom prst="roundRect">
-            <a:avLst>
-              <a:gd name="adj" fmla="val 50000"/>
-            </a:avLst>
-          </a:prstGeom>
-          <a:solidFill>
-            <a:srgbClr val="0A0A0A"/>
-          </a:solidFill>
-          <a:ln/>
-          <a:effectLst>
-            <a:outerShdw sx="100000" sy="100000" kx="0" ky="0" algn="bl" rotWithShape="0" blurRad="177800" dist="76200" dir="5400000">
-              <a:srgbClr val="000000">
-                <a:alpha val="22000"/>
-              </a:srgbClr>
-            </a:outerShdw>
-          </a:effectLst>
-        </p:spPr>
-      </p:sp>
-      <p:pic>
-        <p:nvPicPr>
-          <p:cNvPr id="15" name="svg-14" descr="preencoded.png">    </p:cNvPr>
-          <p:cNvPicPr>
-            <a:picLocks noChangeAspect="1"/>
-          </p:cNvPicPr>
-          <p:nvPr/>
-        </p:nvPicPr>
-        <p:blipFill>
-          <a:blip r:embed="rId5"/>
-          <a:stretch>
-            <a:fillRect/>
-          </a:stretch>
-        </p:blipFill>
-        <p:spPr>
-          <a:xfrm rot="300000">
-            <a:off x="4706218" y="6785882"/>
-            <a:ext cx="203200" cy="203200"/>
-          </a:xfrm>
-          <a:prstGeom prst="rect">
-            <a:avLst/>
-          </a:prstGeom>
-        </p:spPr>
-      </p:pic>
-      <p:sp>
-        <p:nvSpPr>
-          <p:cNvPr id="16" name="text-15"/>
-          <p:cNvSpPr txBox="1"/>
-          <p:nvPr/>
-        </p:nvSpPr>
-        <p:spPr>
-          <a:xfrm rot="300000">
-            <a:off x="4983425" y="6832076"/>
-            <a:ext cx="1285621" cy="247650"/>
-          </a:xfrm>
-          <a:prstGeom prst="rect">
-            <a:avLst/>
-          </a:prstGeom>
-          <a:noFill/>
-          <a:ln/>
-        </p:spPr>
-        <p:txBody>
-          <a:bodyPr wrap="square" lIns="0" tIns="0" rIns="0" bIns="0" rtlCol="0" anchor="t"/>
-          <a:lstStyle/>
-          <a:p>
-            <a:pPr algn="l" indent="0" marL="0">
-              <a:lnSpc>
-                <a:spcPts val="1800"/>
-              </a:lnSpc>
-              <a:buNone/>
-            </a:pPr>
-            <a:r>
-              <a:rPr lang="en-US" sz="1500" b="1" spc="-10" kern="0" dirty="0">
-                <a:solidFill>
-                  <a:srgbClr val="FAF8F3"/>
-                </a:solidFill>
-                <a:latin typeface="Geist" pitchFamily="34" charset="0"/>
-                <a:ea typeface="Geist" pitchFamily="34" charset="-122"/>
-                <a:cs typeface="Geist" pitchFamily="34" charset="-120"/>
-              </a:rPr>
-              <a:t>спасибо, бро</a:t>
-            </a:r>
-            <a:endParaRPr lang="en-US" sz="1500" dirty="0"/>
           </a:p>
         </p:txBody>
       </p:sp>

</xml_diff>